<commit_message>
Lehrerbezogene Metatexte aus Praesentationen entfernen
</commit_message>
<xml_diff>
--- a/_site/ef/01-funktionen-und-analysis/wiederholung.pptx
+++ b/_site/ef/01-funktionen-und-analysis/wiederholung.pptx
@@ -464,746 +464,707 @@
 </file>
 
 <file path=ppt/notesSlides/notesSlide1.xml><?xml version="1.0" encoding="utf-8"?>
-<p:notes xmlns:a="http://schemas.openxmlformats.org/drawingml/2006/main" xmlns:r="http://schemas.openxmlformats.org/officeDocument/2006/relationships" xmlns:p="http://schemas.openxmlformats.org/presentationml/2006/main">
-  <p:cSld>
-    <p:spTree>
-      <p:nvGrpSpPr>
-        <p:cNvPr id="1" name=""/>
-        <p:cNvGrpSpPr/>
-        <p:nvPr/>
-      </p:nvGrpSpPr>
-      <p:grpSpPr>
+<ns0:notes xmlns:a="http://schemas.openxmlformats.org/drawingml/2006/main" xmlns:ns0="http://schemas.openxmlformats.org/presentationml/2006/main" xmlns:ns2="http://schemas.microsoft.com/office/powerpoint/2010/main">
+  <ns0:cSld>
+    <ns0:spTree>
+      <ns0:nvGrpSpPr>
+        <ns0:cNvPr id="1" name=""/>
+        <ns0:cNvGrpSpPr/>
+        <ns0:nvPr/>
+      </ns0:nvGrpSpPr>
+      <ns0:grpSpPr>
         <a:xfrm>
           <a:off x="0" y="0"/>
           <a:ext cx="0" cy="0"/>
           <a:chOff x="0" y="0"/>
           <a:chExt cx="0" cy="0"/>
         </a:xfrm>
-      </p:grpSpPr>
-      <p:sp>
-        <p:nvSpPr>
-          <p:cNvPr id="2" name="Slide Image Placeholder 1"/>
-          <p:cNvSpPr>
+      </ns0:grpSpPr>
+      <ns0:sp>
+        <ns0:nvSpPr>
+          <ns0:cNvPr id="2" name="Slide Image Placeholder 1"/>
+          <ns0:cNvSpPr>
             <a:spLocks noGrp="1" noRot="1" noChangeAspect="1"/>
-          </p:cNvSpPr>
-          <p:nvPr>
-            <p:ph type="sldImg"/>
-          </p:nvPr>
-        </p:nvSpPr>
-        <p:spPr/>
-      </p:sp>
-      <p:sp>
-        <p:nvSpPr>
-          <p:cNvPr id="3" name="Notes Placeholder 2"/>
-          <p:cNvSpPr>
+          </ns0:cNvSpPr>
+          <ns0:nvPr>
+            <ns0:ph type="sldImg"/>
+          </ns0:nvPr>
+        </ns0:nvSpPr>
+        <ns0:spPr/>
+      </ns0:sp>
+      <ns0:sp>
+        <ns0:nvSpPr>
+          <ns0:cNvPr id="3" name="Notes Placeholder 2"/>
+          <ns0:cNvSpPr>
             <a:spLocks noGrp="1"/>
-          </p:cNvSpPr>
-          <p:nvPr>
-            <p:ph type="body" idx="1"/>
-          </p:nvPr>
-        </p:nvSpPr>
-        <p:spPr/>
-        <p:txBody>
+          </ns0:cNvSpPr>
+          <ns0:nvPr>
+            <ns0:ph type="body" idx="1"/>
+          </ns0:nvPr>
+        </ns0:nvSpPr>
+        <ns0:spPr/>
+        <ns0:txBody>
           <a:bodyPr/>
           <a:lstStyle/>
           <a:p>
             <a:r>
               <a:rPr lang="en-US" dirty="0"/>
-              <a:t>Themengebiet: Funktionen und Analysis
-Stufe: Einführungsphase (EF)
-Die Präsentation ist als kurze Wiederholung vor bzw. zu Beginn einer Unterrichtsphase gedacht.</a:t>
+              <a:t/>
             </a:r>
             <a:endParaRPr lang="en-US" dirty="0"/>
           </a:p>
-        </p:txBody>
-      </p:sp>
-      <p:sp>
-        <p:nvSpPr>
-          <p:cNvPr id="4" name="Slide Number Placeholder 3"/>
-          <p:cNvSpPr>
+        </ns0:txBody>
+      </ns0:sp>
+      <ns0:sp>
+        <ns0:nvSpPr>
+          <ns0:cNvPr id="4" name="Slide Number Placeholder 3"/>
+          <ns0:cNvSpPr>
             <a:spLocks noGrp="1"/>
-          </p:cNvSpPr>
-          <p:nvPr>
-            <p:ph type="sldNum" sz="quarter" idx="10"/>
-          </p:nvPr>
-        </p:nvSpPr>
-        <p:spPr/>
-        <p:txBody>
+          </ns0:cNvSpPr>
+          <ns0:nvPr>
+            <ns0:ph type="sldNum" sz="quarter" idx="10"/>
+          </ns0:nvPr>
+        </ns0:nvSpPr>
+        <ns0:spPr/>
+        <ns0:txBody>
           <a:bodyPr/>
           <a:lstStyle/>
           <a:p>
             <a:fld id="{F7021451-1387-4CA6-816F-3879F97B5CBC}" type="slidenum">
               <a:rPr lang="en-US"/>
-              <a:t>1</a:t>
+              <a:t/>
             </a:fld>
             <a:endParaRPr lang="en-US"/>
           </a:p>
-        </p:txBody>
-      </p:sp>
-    </p:spTree>
-    <p:extLst>
-      <p:ext uri="{BB962C8B-B14F-4D97-AF65-F5344CB8AC3E}">
-        <p14:creationId xmlns:p14="http://schemas.microsoft.com/office/powerpoint/2010/main" val="1024086991"/>
-      </p:ext>
-    </p:extLst>
-  </p:cSld>
-  <p:clrMapOvr>
+        </ns0:txBody>
+      </ns0:sp>
+    </ns0:spTree>
+    <ns0:extLst>
+      <ns0:ext uri="{BB962C8B-B14F-4D97-AF65-F5344CB8AC3E}">
+        <ns2:creationId val="1024086991"/>
+      </ns0:ext>
+    </ns0:extLst>
+  </ns0:cSld>
+  <ns0:clrMapOvr>
     <a:masterClrMapping/>
-  </p:clrMapOvr>
-</p:notes>
+  </ns0:clrMapOvr>
+</ns0:notes>
 </file>
 
 <file path=ppt/notesSlides/notesSlide2.xml><?xml version="1.0" encoding="utf-8"?>
-<p:notes xmlns:a="http://schemas.openxmlformats.org/drawingml/2006/main" xmlns:r="http://schemas.openxmlformats.org/officeDocument/2006/relationships" xmlns:p="http://schemas.openxmlformats.org/presentationml/2006/main">
-  <p:cSld>
-    <p:spTree>
-      <p:nvGrpSpPr>
-        <p:cNvPr id="1" name=""/>
-        <p:cNvGrpSpPr/>
-        <p:nvPr/>
-      </p:nvGrpSpPr>
-      <p:grpSpPr>
+<ns0:notes xmlns:a="http://schemas.openxmlformats.org/drawingml/2006/main" xmlns:ns0="http://schemas.openxmlformats.org/presentationml/2006/main" xmlns:ns2="http://schemas.microsoft.com/office/powerpoint/2010/main">
+  <ns0:cSld>
+    <ns0:spTree>
+      <ns0:nvGrpSpPr>
+        <ns0:cNvPr id="1" name=""/>
+        <ns0:cNvGrpSpPr/>
+        <ns0:nvPr/>
+      </ns0:nvGrpSpPr>
+      <ns0:grpSpPr>
         <a:xfrm>
           <a:off x="0" y="0"/>
           <a:ext cx="0" cy="0"/>
           <a:chOff x="0" y="0"/>
           <a:chExt cx="0" cy="0"/>
         </a:xfrm>
-      </p:grpSpPr>
-      <p:sp>
-        <p:nvSpPr>
-          <p:cNvPr id="2" name="Slide Image Placeholder 1"/>
-          <p:cNvSpPr>
+      </ns0:grpSpPr>
+      <ns0:sp>
+        <ns0:nvSpPr>
+          <ns0:cNvPr id="2" name="Slide Image Placeholder 1"/>
+          <ns0:cNvSpPr>
             <a:spLocks noGrp="1" noRot="1" noChangeAspect="1"/>
-          </p:cNvSpPr>
-          <p:nvPr>
-            <p:ph type="sldImg"/>
-          </p:nvPr>
-        </p:nvSpPr>
-        <p:spPr/>
-      </p:sp>
-      <p:sp>
-        <p:nvSpPr>
-          <p:cNvPr id="3" name="Notes Placeholder 2"/>
-          <p:cNvSpPr>
+          </ns0:cNvSpPr>
+          <ns0:nvPr>
+            <ns0:ph type="sldImg"/>
+          </ns0:nvPr>
+        </ns0:nvSpPr>
+        <ns0:spPr/>
+      </ns0:sp>
+      <ns0:sp>
+        <ns0:nvSpPr>
+          <ns0:cNvPr id="3" name="Notes Placeholder 2"/>
+          <ns0:cNvSpPr>
             <a:spLocks noGrp="1"/>
-          </p:cNvSpPr>
-          <p:nvPr>
-            <p:ph type="body" idx="1"/>
-          </p:nvPr>
-        </p:nvSpPr>
-        <p:spPr/>
-        <p:txBody>
+          </ns0:cNvSpPr>
+          <ns0:nvPr>
+            <ns0:ph type="body" idx="1"/>
+          </ns0:nvPr>
+        </ns0:nvSpPr>
+        <ns0:spPr/>
+        <ns0:txBody>
           <a:bodyPr/>
           <a:lstStyle/>
           <a:p>
             <a:r>
               <a:rPr lang="en-US" dirty="0"/>
-              <a:t>1. Bestimme f(2) für f(x)=x³−2x.
-Lösung: 4.
-2. Was bewirkt f(x−3) gegenüber f(x)?
-Lösung: Verschiebung um 3 nach rechts.
-3. Was berechnet (f(b)−f(a))/(b−a)?
-Lösung: Die mittlere Änderungsrate auf [a,b].
-4. Was ist f′(x₀) geometrisch?
-Lösung: Steigung der Tangente an f im Punkt x₀.</a:t>
+              <a:t/>
             </a:r>
             <a:endParaRPr lang="en-US" dirty="0"/>
           </a:p>
-        </p:txBody>
-      </p:sp>
-      <p:sp>
-        <p:nvSpPr>
-          <p:cNvPr id="4" name="Slide Number Placeholder 3"/>
-          <p:cNvSpPr>
+        </ns0:txBody>
+      </ns0:sp>
+      <ns0:sp>
+        <ns0:nvSpPr>
+          <ns0:cNvPr id="4" name="Slide Number Placeholder 3"/>
+          <ns0:cNvSpPr>
             <a:spLocks noGrp="1"/>
-          </p:cNvSpPr>
-          <p:nvPr>
-            <p:ph type="sldNum" sz="quarter" idx="10"/>
-          </p:nvPr>
-        </p:nvSpPr>
-        <p:spPr/>
-        <p:txBody>
+          </ns0:cNvSpPr>
+          <ns0:nvPr>
+            <ns0:ph type="sldNum" sz="quarter" idx="10"/>
+          </ns0:nvPr>
+        </ns0:nvSpPr>
+        <ns0:spPr/>
+        <ns0:txBody>
           <a:bodyPr/>
           <a:lstStyle/>
           <a:p>
             <a:fld id="{F7021451-1387-4CA6-816F-3879F97B5CBC}" type="slidenum">
               <a:rPr lang="en-US"/>
-              <a:t>2</a:t>
+              <a:t/>
             </a:fld>
             <a:endParaRPr lang="en-US"/>
           </a:p>
-        </p:txBody>
-      </p:sp>
-    </p:spTree>
-    <p:extLst>
-      <p:ext uri="{BB962C8B-B14F-4D97-AF65-F5344CB8AC3E}">
-        <p14:creationId xmlns:p14="http://schemas.microsoft.com/office/powerpoint/2010/main" val="1024086991"/>
-      </p:ext>
-    </p:extLst>
-  </p:cSld>
-  <p:clrMapOvr>
+        </ns0:txBody>
+      </ns0:sp>
+    </ns0:spTree>
+    <ns0:extLst>
+      <ns0:ext uri="{BB962C8B-B14F-4D97-AF65-F5344CB8AC3E}">
+        <ns2:creationId val="1024086991"/>
+      </ns0:ext>
+    </ns0:extLst>
+  </ns0:cSld>
+  <ns0:clrMapOvr>
     <a:masterClrMapping/>
-  </p:clrMapOvr>
-</p:notes>
+  </ns0:clrMapOvr>
+</ns0:notes>
 </file>
 
 <file path=ppt/notesSlides/notesSlide3.xml><?xml version="1.0" encoding="utf-8"?>
-<p:notes xmlns:a="http://schemas.openxmlformats.org/drawingml/2006/main" xmlns:r="http://schemas.openxmlformats.org/officeDocument/2006/relationships" xmlns:p="http://schemas.openxmlformats.org/presentationml/2006/main">
-  <p:cSld>
-    <p:spTree>
-      <p:nvGrpSpPr>
-        <p:cNvPr id="1" name=""/>
-        <p:cNvGrpSpPr/>
-        <p:nvPr/>
-      </p:nvGrpSpPr>
-      <p:grpSpPr>
+<ns0:notes xmlns:a="http://schemas.openxmlformats.org/drawingml/2006/main" xmlns:ns0="http://schemas.openxmlformats.org/presentationml/2006/main" xmlns:ns2="http://schemas.microsoft.com/office/powerpoint/2010/main">
+  <ns0:cSld>
+    <ns0:spTree>
+      <ns0:nvGrpSpPr>
+        <ns0:cNvPr id="1" name=""/>
+        <ns0:cNvGrpSpPr/>
+        <ns0:nvPr/>
+      </ns0:nvGrpSpPr>
+      <ns0:grpSpPr>
         <a:xfrm>
           <a:off x="0" y="0"/>
           <a:ext cx="0" cy="0"/>
           <a:chOff x="0" y="0"/>
           <a:chExt cx="0" cy="0"/>
         </a:xfrm>
-      </p:grpSpPr>
-      <p:sp>
-        <p:nvSpPr>
-          <p:cNvPr id="2" name="Slide Image Placeholder 1"/>
-          <p:cNvSpPr>
+      </ns0:grpSpPr>
+      <ns0:sp>
+        <ns0:nvSpPr>
+          <ns0:cNvPr id="2" name="Slide Image Placeholder 1"/>
+          <ns0:cNvSpPr>
             <a:spLocks noGrp="1" noRot="1" noChangeAspect="1"/>
-          </p:cNvSpPr>
-          <p:nvPr>
-            <p:ph type="sldImg"/>
-          </p:nvPr>
-        </p:nvSpPr>
-        <p:spPr/>
-      </p:sp>
-      <p:sp>
-        <p:nvSpPr>
-          <p:cNvPr id="3" name="Notes Placeholder 2"/>
-          <p:cNvSpPr>
+          </ns0:cNvSpPr>
+          <ns0:nvPr>
+            <ns0:ph type="sldImg"/>
+          </ns0:nvPr>
+        </ns0:nvSpPr>
+        <ns0:spPr/>
+      </ns0:sp>
+      <ns0:sp>
+        <ns0:nvSpPr>
+          <ns0:cNvPr id="3" name="Notes Placeholder 2"/>
+          <ns0:cNvSpPr>
             <a:spLocks noGrp="1"/>
-          </p:cNvSpPr>
-          <p:nvPr>
-            <p:ph type="body" idx="1"/>
-          </p:nvPr>
-        </p:nvSpPr>
-        <p:spPr/>
-        <p:txBody>
+          </ns0:cNvSpPr>
+          <ns0:nvPr>
+            <ns0:ph type="body" idx="1"/>
+          </ns0:nvPr>
+        </ns0:nvSpPr>
+        <ns0:spPr/>
+        <ns0:txBody>
           <a:bodyPr/>
           <a:lstStyle/>
           <a:p>
             <a:r>
               <a:rPr lang="en-US" dirty="0"/>
-              <a:t>1. Welche typischen Symmetrien besitzen x² und x³?
-Lösung: x² achsensymmetrisch zur y-Achse; x³ punktsymmetrisch zum Ursprung.
-2. Wie erkennt man y-Achsensymmetrie algebraisch?
-Lösung: f(−x)=f(x).
-3. Was ist geometrisch der Unterschied zwischen Sekante und Tangente?
-Lösung: Sekante verbindet zwei Punkte; Tangente beschreibt die lokale Richtung in einem Punkt.</a:t>
+              <a:t/>
             </a:r>
             <a:endParaRPr lang="en-US" dirty="0"/>
           </a:p>
-        </p:txBody>
-      </p:sp>
-      <p:sp>
-        <p:nvSpPr>
-          <p:cNvPr id="4" name="Slide Number Placeholder 3"/>
-          <p:cNvSpPr>
+        </ns0:txBody>
+      </ns0:sp>
+      <ns0:sp>
+        <ns0:nvSpPr>
+          <ns0:cNvPr id="4" name="Slide Number Placeholder 3"/>
+          <ns0:cNvSpPr>
             <a:spLocks noGrp="1"/>
-          </p:cNvSpPr>
-          <p:nvPr>
-            <p:ph type="sldNum" sz="quarter" idx="10"/>
-          </p:nvPr>
-        </p:nvSpPr>
-        <p:spPr/>
-        <p:txBody>
+          </ns0:cNvSpPr>
+          <ns0:nvPr>
+            <ns0:ph type="sldNum" sz="quarter" idx="10"/>
+          </ns0:nvPr>
+        </ns0:nvSpPr>
+        <ns0:spPr/>
+        <ns0:txBody>
           <a:bodyPr/>
           <a:lstStyle/>
           <a:p>
             <a:fld id="{F7021451-1387-4CA6-816F-3879F97B5CBC}" type="slidenum">
               <a:rPr lang="en-US"/>
-              <a:t>3</a:t>
+              <a:t/>
             </a:fld>
             <a:endParaRPr lang="en-US"/>
           </a:p>
-        </p:txBody>
-      </p:sp>
-    </p:spTree>
-    <p:extLst>
-      <p:ext uri="{BB962C8B-B14F-4D97-AF65-F5344CB8AC3E}">
-        <p14:creationId xmlns:p14="http://schemas.microsoft.com/office/powerpoint/2010/main" val="1024086991"/>
-      </p:ext>
-    </p:extLst>
-  </p:cSld>
-  <p:clrMapOvr>
+        </ns0:txBody>
+      </ns0:sp>
+    </ns0:spTree>
+    <ns0:extLst>
+      <ns0:ext uri="{BB962C8B-B14F-4D97-AF65-F5344CB8AC3E}">
+        <ns2:creationId val="1024086991"/>
+      </ns0:ext>
+    </ns0:extLst>
+  </ns0:cSld>
+  <ns0:clrMapOvr>
     <a:masterClrMapping/>
-  </p:clrMapOvr>
-</p:notes>
+  </ns0:clrMapOvr>
+</ns0:notes>
 </file>
 
 <file path=ppt/notesSlides/notesSlide4.xml><?xml version="1.0" encoding="utf-8"?>
-<p:notes xmlns:a="http://schemas.openxmlformats.org/drawingml/2006/main" xmlns:r="http://schemas.openxmlformats.org/officeDocument/2006/relationships" xmlns:p="http://schemas.openxmlformats.org/presentationml/2006/main">
-  <p:cSld>
-    <p:spTree>
-      <p:nvGrpSpPr>
-        <p:cNvPr id="1" name=""/>
-        <p:cNvGrpSpPr/>
-        <p:nvPr/>
-      </p:nvGrpSpPr>
-      <p:grpSpPr>
+<ns0:notes xmlns:a="http://schemas.openxmlformats.org/drawingml/2006/main" xmlns:ns0="http://schemas.openxmlformats.org/presentationml/2006/main" xmlns:ns2="http://schemas.microsoft.com/office/powerpoint/2010/main">
+  <ns0:cSld>
+    <ns0:spTree>
+      <ns0:nvGrpSpPr>
+        <ns0:cNvPr id="1" name=""/>
+        <ns0:cNvGrpSpPr/>
+        <ns0:nvPr/>
+      </ns0:nvGrpSpPr>
+      <ns0:grpSpPr>
         <a:xfrm>
           <a:off x="0" y="0"/>
           <a:ext cx="0" cy="0"/>
           <a:chOff x="0" y="0"/>
           <a:chExt cx="0" cy="0"/>
         </a:xfrm>
-      </p:grpSpPr>
-      <p:sp>
-        <p:nvSpPr>
-          <p:cNvPr id="2" name="Slide Image Placeholder 1"/>
-          <p:cNvSpPr>
+      </ns0:grpSpPr>
+      <ns0:sp>
+        <ns0:nvSpPr>
+          <ns0:cNvPr id="2" name="Slide Image Placeholder 1"/>
+          <ns0:cNvSpPr>
             <a:spLocks noGrp="1" noRot="1" noChangeAspect="1"/>
-          </p:cNvSpPr>
-          <p:nvPr>
-            <p:ph type="sldImg"/>
-          </p:nvPr>
-        </p:nvSpPr>
-        <p:spPr/>
-      </p:sp>
-      <p:sp>
-        <p:nvSpPr>
-          <p:cNvPr id="3" name="Notes Placeholder 2"/>
-          <p:cNvSpPr>
+          </ns0:cNvSpPr>
+          <ns0:nvPr>
+            <ns0:ph type="sldImg"/>
+          </ns0:nvPr>
+        </ns0:nvSpPr>
+        <ns0:spPr/>
+      </ns0:sp>
+      <ns0:sp>
+        <ns0:nvSpPr>
+          <ns0:cNvPr id="3" name="Notes Placeholder 2"/>
+          <ns0:cNvSpPr>
             <a:spLocks noGrp="1"/>
-          </p:cNvSpPr>
-          <p:nvPr>
-            <p:ph type="body" idx="1"/>
-          </p:nvPr>
-        </p:nvSpPr>
-        <p:spPr/>
-        <p:txBody>
+          </ns0:cNvSpPr>
+          <ns0:nvPr>
+            <ns0:ph type="body" idx="1"/>
+          </ns0:nvPr>
+        </ns0:nvSpPr>
+        <ns0:spPr/>
+        <ns0:txBody>
           <a:bodyPr/>
           <a:lstStyle/>
           <a:p>
             <a:r>
               <a:rPr lang="en-US" dirty="0"/>
-              <a:t>1. Bestimme die Nullstellen von x³−4x.
-Lösung: x(x−2)(x+2)=0 → −2,0,2.
-2. Beschreibe g(x)=−2·f(x)+1.
-Lösung: Spiegelung an x-Achse, Streckung Faktor 2, Verschiebung um 1 nach oben.
-3. f(x)=x²: mittlere Änderungsrate von 1 bis 3.
-Lösung: (9−1)/(3−1)=4.</a:t>
+              <a:t/>
             </a:r>
             <a:endParaRPr lang="en-US" dirty="0"/>
           </a:p>
-        </p:txBody>
-      </p:sp>
-      <p:sp>
-        <p:nvSpPr>
-          <p:cNvPr id="4" name="Slide Number Placeholder 3"/>
-          <p:cNvSpPr>
+        </ns0:txBody>
+      </ns0:sp>
+      <ns0:sp>
+        <ns0:nvSpPr>
+          <ns0:cNvPr id="4" name="Slide Number Placeholder 3"/>
+          <ns0:cNvSpPr>
             <a:spLocks noGrp="1"/>
-          </p:cNvSpPr>
-          <p:nvPr>
-            <p:ph type="sldNum" sz="quarter" idx="10"/>
-          </p:nvPr>
-        </p:nvSpPr>
-        <p:spPr/>
-        <p:txBody>
+          </ns0:cNvSpPr>
+          <ns0:nvPr>
+            <ns0:ph type="sldNum" sz="quarter" idx="10"/>
+          </ns0:nvPr>
+        </ns0:nvSpPr>
+        <ns0:spPr/>
+        <ns0:txBody>
           <a:bodyPr/>
           <a:lstStyle/>
           <a:p>
             <a:fld id="{F7021451-1387-4CA6-816F-3879F97B5CBC}" type="slidenum">
               <a:rPr lang="en-US"/>
-              <a:t>4</a:t>
+              <a:t/>
             </a:fld>
             <a:endParaRPr lang="en-US"/>
           </a:p>
-        </p:txBody>
-      </p:sp>
-    </p:spTree>
-    <p:extLst>
-      <p:ext uri="{BB962C8B-B14F-4D97-AF65-F5344CB8AC3E}">
-        <p14:creationId xmlns:p14="http://schemas.microsoft.com/office/powerpoint/2010/main" val="1024086991"/>
-      </p:ext>
-    </p:extLst>
-  </p:cSld>
-  <p:clrMapOvr>
+        </ns0:txBody>
+      </ns0:sp>
+    </ns0:spTree>
+    <ns0:extLst>
+      <ns0:ext uri="{BB962C8B-B14F-4D97-AF65-F5344CB8AC3E}">
+        <ns2:creationId val="1024086991"/>
+      </ns0:ext>
+    </ns0:extLst>
+  </ns0:cSld>
+  <ns0:clrMapOvr>
     <a:masterClrMapping/>
-  </p:clrMapOvr>
-</p:notes>
+  </ns0:clrMapOvr>
+</ns0:notes>
 </file>
 
 <file path=ppt/notesSlides/notesSlide5.xml><?xml version="1.0" encoding="utf-8"?>
-<p:notes xmlns:a="http://schemas.openxmlformats.org/drawingml/2006/main" xmlns:r="http://schemas.openxmlformats.org/officeDocument/2006/relationships" xmlns:p="http://schemas.openxmlformats.org/presentationml/2006/main">
-  <p:cSld>
-    <p:spTree>
-      <p:nvGrpSpPr>
-        <p:cNvPr id="1" name=""/>
-        <p:cNvGrpSpPr/>
-        <p:nvPr/>
-      </p:nvGrpSpPr>
-      <p:grpSpPr>
+<ns0:notes xmlns:a="http://schemas.openxmlformats.org/drawingml/2006/main" xmlns:ns0="http://schemas.openxmlformats.org/presentationml/2006/main" xmlns:ns2="http://schemas.microsoft.com/office/powerpoint/2010/main">
+  <ns0:cSld>
+    <ns0:spTree>
+      <ns0:nvGrpSpPr>
+        <ns0:cNvPr id="1" name=""/>
+        <ns0:cNvGrpSpPr/>
+        <ns0:nvPr/>
+      </ns0:nvGrpSpPr>
+      <ns0:grpSpPr>
         <a:xfrm>
           <a:off x="0" y="0"/>
           <a:ext cx="0" cy="0"/>
           <a:chOff x="0" y="0"/>
           <a:chExt cx="0" cy="0"/>
         </a:xfrm>
-      </p:grpSpPr>
-      <p:sp>
-        <p:nvSpPr>
-          <p:cNvPr id="2" name="Slide Image Placeholder 1"/>
-          <p:cNvSpPr>
+      </ns0:grpSpPr>
+      <ns0:sp>
+        <ns0:nvSpPr>
+          <ns0:cNvPr id="2" name="Slide Image Placeholder 1"/>
+          <ns0:cNvSpPr>
             <a:spLocks noGrp="1" noRot="1" noChangeAspect="1"/>
-          </p:cNvSpPr>
-          <p:nvPr>
-            <p:ph type="sldImg"/>
-          </p:nvPr>
-        </p:nvSpPr>
-        <p:spPr/>
-      </p:sp>
-      <p:sp>
-        <p:nvSpPr>
-          <p:cNvPr id="3" name="Notes Placeholder 2"/>
-          <p:cNvSpPr>
+          </ns0:cNvSpPr>
+          <ns0:nvPr>
+            <ns0:ph type="sldImg"/>
+          </ns0:nvPr>
+        </ns0:nvSpPr>
+        <ns0:spPr/>
+      </ns0:sp>
+      <ns0:sp>
+        <ns0:nvSpPr>
+          <ns0:cNvPr id="3" name="Notes Placeholder 2"/>
+          <ns0:cNvSpPr>
             <a:spLocks noGrp="1"/>
-          </p:cNvSpPr>
-          <p:nvPr>
-            <p:ph type="body" idx="1"/>
-          </p:nvPr>
-        </p:nvSpPr>
-        <p:spPr/>
-        <p:txBody>
+          </ns0:cNvSpPr>
+          <ns0:nvPr>
+            <ns0:ph type="body" idx="1"/>
+          </ns0:nvPr>
+        </ns0:nvSpPr>
+        <ns0:spPr/>
+        <ns0:txBody>
           <a:bodyPr/>
           <a:lstStyle/>
           <a:p>
             <a:r>
               <a:rPr lang="en-US" dirty="0"/>
-              <a:t>1. Wie erkennt man y-Achsensymmetrie algebraisch?
-Lösung: f(−x)=f(x).
-2. f(x)=x²: mittlere Änderungsrate von 1 bis 3.
-Lösung: (9−1)/(3−1)=4.</a:t>
+              <a:t/>
             </a:r>
             <a:endParaRPr lang="en-US" dirty="0"/>
           </a:p>
-        </p:txBody>
-      </p:sp>
-      <p:sp>
-        <p:nvSpPr>
-          <p:cNvPr id="4" name="Slide Number Placeholder 3"/>
-          <p:cNvSpPr>
+        </ns0:txBody>
+      </ns0:sp>
+      <ns0:sp>
+        <ns0:nvSpPr>
+          <ns0:cNvPr id="4" name="Slide Number Placeholder 3"/>
+          <ns0:cNvSpPr>
             <a:spLocks noGrp="1"/>
-          </p:cNvSpPr>
-          <p:nvPr>
-            <p:ph type="sldNum" sz="quarter" idx="10"/>
-          </p:nvPr>
-        </p:nvSpPr>
-        <p:spPr/>
-        <p:txBody>
+          </ns0:cNvSpPr>
+          <ns0:nvPr>
+            <ns0:ph type="sldNum" sz="quarter" idx="10"/>
+          </ns0:nvPr>
+        </ns0:nvSpPr>
+        <ns0:spPr/>
+        <ns0:txBody>
           <a:bodyPr/>
           <a:lstStyle/>
           <a:p>
             <a:fld id="{F7021451-1387-4CA6-816F-3879F97B5CBC}" type="slidenum">
               <a:rPr lang="en-US"/>
-              <a:t>5</a:t>
+              <a:t/>
             </a:fld>
             <a:endParaRPr lang="en-US"/>
           </a:p>
-        </p:txBody>
-      </p:sp>
-    </p:spTree>
-    <p:extLst>
-      <p:ext uri="{BB962C8B-B14F-4D97-AF65-F5344CB8AC3E}">
-        <p14:creationId xmlns:p14="http://schemas.microsoft.com/office/powerpoint/2010/main" val="1024086991"/>
-      </p:ext>
-    </p:extLst>
-  </p:cSld>
-  <p:clrMapOvr>
+        </ns0:txBody>
+      </ns0:sp>
+    </ns0:spTree>
+    <ns0:extLst>
+      <ns0:ext uri="{BB962C8B-B14F-4D97-AF65-F5344CB8AC3E}">
+        <ns2:creationId val="1024086991"/>
+      </ns0:ext>
+    </ns0:extLst>
+  </ns0:cSld>
+  <ns0:clrMapOvr>
     <a:masterClrMapping/>
-  </p:clrMapOvr>
-</p:notes>
+  </ns0:clrMapOvr>
+</ns0:notes>
 </file>
 
 <file path=ppt/notesSlides/notesSlide6.xml><?xml version="1.0" encoding="utf-8"?>
-<p:notes xmlns:a="http://schemas.openxmlformats.org/drawingml/2006/main" xmlns:r="http://schemas.openxmlformats.org/officeDocument/2006/relationships" xmlns:p="http://schemas.openxmlformats.org/presentationml/2006/main">
-  <p:cSld>
-    <p:spTree>
-      <p:nvGrpSpPr>
-        <p:cNvPr id="1" name=""/>
-        <p:cNvGrpSpPr/>
-        <p:nvPr/>
-      </p:nvGrpSpPr>
-      <p:grpSpPr>
+<ns0:notes xmlns:a="http://schemas.openxmlformats.org/drawingml/2006/main" xmlns:ns0="http://schemas.openxmlformats.org/presentationml/2006/main" xmlns:ns2="http://schemas.microsoft.com/office/powerpoint/2010/main">
+  <ns0:cSld>
+    <ns0:spTree>
+      <ns0:nvGrpSpPr>
+        <ns0:cNvPr id="1" name=""/>
+        <ns0:cNvGrpSpPr/>
+        <ns0:nvPr/>
+      </ns0:nvGrpSpPr>
+      <ns0:grpSpPr>
         <a:xfrm>
           <a:off x="0" y="0"/>
           <a:ext cx="0" cy="0"/>
           <a:chOff x="0" y="0"/>
           <a:chExt cx="0" cy="0"/>
         </a:xfrm>
-      </p:grpSpPr>
-      <p:sp>
-        <p:nvSpPr>
-          <p:cNvPr id="2" name="Slide Image Placeholder 1"/>
-          <p:cNvSpPr>
+      </ns0:grpSpPr>
+      <ns0:sp>
+        <ns0:nvSpPr>
+          <ns0:cNvPr id="2" name="Slide Image Placeholder 1"/>
+          <ns0:cNvSpPr>
             <a:spLocks noGrp="1" noRot="1" noChangeAspect="1"/>
-          </p:cNvSpPr>
-          <p:nvPr>
-            <p:ph type="sldImg"/>
-          </p:nvPr>
-        </p:nvSpPr>
-        <p:spPr/>
-      </p:sp>
-      <p:sp>
-        <p:nvSpPr>
-          <p:cNvPr id="3" name="Notes Placeholder 2"/>
-          <p:cNvSpPr>
+          </ns0:cNvSpPr>
+          <ns0:nvPr>
+            <ns0:ph type="sldImg"/>
+          </ns0:nvPr>
+        </ns0:nvSpPr>
+        <ns0:spPr/>
+      </ns0:sp>
+      <ns0:sp>
+        <ns0:nvSpPr>
+          <ns0:cNvPr id="3" name="Notes Placeholder 2"/>
+          <ns0:cNvSpPr>
             <a:spLocks noGrp="1"/>
-          </p:cNvSpPr>
-          <p:nvPr>
-            <p:ph type="body" idx="1"/>
-          </p:nvPr>
-        </p:nvSpPr>
-        <p:spPr/>
-        <p:txBody>
+          </ns0:cNvSpPr>
+          <ns0:nvPr>
+            <ns0:ph type="body" idx="1"/>
+          </ns0:nvPr>
+        </ns0:nvSpPr>
+        <ns0:spPr/>
+        <ns0:txBody>
           <a:bodyPr/>
           <a:lstStyle/>
           <a:p>
             <a:r>
               <a:rPr lang="en-US" dirty="0"/>
-              <a:t>1. Wenn f bei x=2 ein lokales Maximum hat: Welche notwendige Bedingung gilt meist?
-Lösung: f′(2)=0 (bei Differenzierbarkeit).
-2. f(x)=x³−3x²: Bestimme kritische Stellen.
-Lösung: f′=3x²−6x=3x(x−2) → x=0,2.</a:t>
+              <a:t/>
             </a:r>
             <a:endParaRPr lang="en-US" dirty="0"/>
           </a:p>
-        </p:txBody>
-      </p:sp>
-      <p:sp>
-        <p:nvSpPr>
-          <p:cNvPr id="4" name="Slide Number Placeholder 3"/>
-          <p:cNvSpPr>
+        </ns0:txBody>
+      </ns0:sp>
+      <ns0:sp>
+        <ns0:nvSpPr>
+          <ns0:cNvPr id="4" name="Slide Number Placeholder 3"/>
+          <ns0:cNvSpPr>
             <a:spLocks noGrp="1"/>
-          </p:cNvSpPr>
-          <p:nvPr>
-            <p:ph type="sldNum" sz="quarter" idx="10"/>
-          </p:nvPr>
-        </p:nvSpPr>
-        <p:spPr/>
-        <p:txBody>
+          </ns0:cNvSpPr>
+          <ns0:nvPr>
+            <ns0:ph type="sldNum" sz="quarter" idx="10"/>
+          </ns0:nvPr>
+        </ns0:nvSpPr>
+        <ns0:spPr/>
+        <ns0:txBody>
           <a:bodyPr/>
           <a:lstStyle/>
           <a:p>
             <a:fld id="{F7021451-1387-4CA6-816F-3879F97B5CBC}" type="slidenum">
               <a:rPr lang="en-US"/>
-              <a:t>6</a:t>
+              <a:t/>
             </a:fld>
             <a:endParaRPr lang="en-US"/>
           </a:p>
-        </p:txBody>
-      </p:sp>
-    </p:spTree>
-    <p:extLst>
-      <p:ext uri="{BB962C8B-B14F-4D97-AF65-F5344CB8AC3E}">
-        <p14:creationId xmlns:p14="http://schemas.microsoft.com/office/powerpoint/2010/main" val="1024086991"/>
-      </p:ext>
-    </p:extLst>
-  </p:cSld>
-  <p:clrMapOvr>
+        </ns0:txBody>
+      </ns0:sp>
+    </ns0:spTree>
+    <ns0:extLst>
+      <ns0:ext uri="{BB962C8B-B14F-4D97-AF65-F5344CB8AC3E}">
+        <ns2:creationId val="1024086991"/>
+      </ns0:ext>
+    </ns0:extLst>
+  </ns0:cSld>
+  <ns0:clrMapOvr>
     <a:masterClrMapping/>
-  </p:clrMapOvr>
-</p:notes>
+  </ns0:clrMapOvr>
+</ns0:notes>
 </file>
 
 <file path=ppt/notesSlides/notesSlide7.xml><?xml version="1.0" encoding="utf-8"?>
-<p:notes xmlns:a="http://schemas.openxmlformats.org/drawingml/2006/main" xmlns:r="http://schemas.openxmlformats.org/officeDocument/2006/relationships" xmlns:p="http://schemas.openxmlformats.org/presentationml/2006/main">
-  <p:cSld>
-    <p:spTree>
-      <p:nvGrpSpPr>
-        <p:cNvPr id="1" name=""/>
-        <p:cNvGrpSpPr/>
-        <p:nvPr/>
-      </p:nvGrpSpPr>
-      <p:grpSpPr>
+<ns0:notes xmlns:a="http://schemas.openxmlformats.org/drawingml/2006/main" xmlns:ns0="http://schemas.openxmlformats.org/presentationml/2006/main" xmlns:ns2="http://schemas.microsoft.com/office/powerpoint/2010/main">
+  <ns0:cSld>
+    <ns0:spTree>
+      <ns0:nvGrpSpPr>
+        <ns0:cNvPr id="1" name=""/>
+        <ns0:cNvGrpSpPr/>
+        <ns0:nvPr/>
+      </ns0:nvGrpSpPr>
+      <ns0:grpSpPr>
         <a:xfrm>
           <a:off x="0" y="0"/>
           <a:ext cx="0" cy="0"/>
           <a:chOff x="0" y="0"/>
           <a:chExt cx="0" cy="0"/>
         </a:xfrm>
-      </p:grpSpPr>
-      <p:sp>
-        <p:nvSpPr>
-          <p:cNvPr id="2" name="Slide Image Placeholder 1"/>
-          <p:cNvSpPr>
+      </ns0:grpSpPr>
+      <ns0:sp>
+        <ns0:nvSpPr>
+          <ns0:cNvPr id="2" name="Slide Image Placeholder 1"/>
+          <ns0:cNvSpPr>
             <a:spLocks noGrp="1" noRot="1" noChangeAspect="1"/>
-          </p:cNvSpPr>
-          <p:nvPr>
-            <p:ph type="sldImg"/>
-          </p:nvPr>
-        </p:nvSpPr>
-        <p:spPr/>
-      </p:sp>
-      <p:sp>
-        <p:nvSpPr>
-          <p:cNvPr id="3" name="Notes Placeholder 2"/>
-          <p:cNvSpPr>
+          </ns0:cNvSpPr>
+          <ns0:nvPr>
+            <ns0:ph type="sldImg"/>
+          </ns0:nvPr>
+        </ns0:nvSpPr>
+        <ns0:spPr/>
+      </ns0:sp>
+      <ns0:sp>
+        <ns0:nvSpPr>
+          <ns0:cNvPr id="3" name="Notes Placeholder 2"/>
+          <ns0:cNvSpPr>
             <a:spLocks noGrp="1"/>
-          </p:cNvSpPr>
-          <p:nvPr>
-            <p:ph type="body" idx="1"/>
-          </p:nvPr>
-        </p:nvSpPr>
-        <p:spPr/>
-        <p:txBody>
+          </ns0:cNvSpPr>
+          <ns0:nvPr>
+            <ns0:ph type="body" idx="1"/>
+          </ns0:nvPr>
+        </ns0:nvSpPr>
+        <ns0:spPr/>
+        <ns0:txBody>
           <a:bodyPr/>
           <a:lstStyle/>
           <a:p>
             <a:r>
               <a:rPr lang="en-US" dirty="0"/>
-              <a:t>1. Wie bestimmt der höchste Exponent das Verhalten für |x|→∞?
-Lösung: Grad und Vorzeichen des Leitkoeffizienten bestimmen das Endverhalten.
-2. Was unterscheidet Wendestelle und Extremstelle?
-Lösung: Extrem: Wechsel von Steigen/Fallen; Wendung: Wechsel des Krümmungsverhaltens.
-3. „Ein steigender Graph hat immer positive Funktionswerte.“ – Korrigiere.
-Lösung: Steigend bedeutet positive Änderungsrate/Steigung; der Funktionswert kann trotzdem negativ sein.</a:t>
+              <a:t/>
             </a:r>
             <a:endParaRPr lang="en-US" dirty="0"/>
           </a:p>
-        </p:txBody>
-      </p:sp>
-      <p:sp>
-        <p:nvSpPr>
-          <p:cNvPr id="4" name="Slide Number Placeholder 3"/>
-          <p:cNvSpPr>
+        </ns0:txBody>
+      </ns0:sp>
+      <ns0:sp>
+        <ns0:nvSpPr>
+          <ns0:cNvPr id="4" name="Slide Number Placeholder 3"/>
+          <ns0:cNvSpPr>
             <a:spLocks noGrp="1"/>
-          </p:cNvSpPr>
-          <p:nvPr>
-            <p:ph type="sldNum" sz="quarter" idx="10"/>
-          </p:nvPr>
-        </p:nvSpPr>
-        <p:spPr/>
-        <p:txBody>
+          </ns0:cNvSpPr>
+          <ns0:nvPr>
+            <ns0:ph type="sldNum" sz="quarter" idx="10"/>
+          </ns0:nvPr>
+        </ns0:nvSpPr>
+        <ns0:spPr/>
+        <ns0:txBody>
           <a:bodyPr/>
           <a:lstStyle/>
           <a:p>
             <a:fld id="{F7021451-1387-4CA6-816F-3879F97B5CBC}" type="slidenum">
               <a:rPr lang="en-US"/>
-              <a:t>7</a:t>
+              <a:t/>
             </a:fld>
             <a:endParaRPr lang="en-US"/>
           </a:p>
-        </p:txBody>
-      </p:sp>
-    </p:spTree>
-    <p:extLst>
-      <p:ext uri="{BB962C8B-B14F-4D97-AF65-F5344CB8AC3E}">
-        <p14:creationId xmlns:p14="http://schemas.microsoft.com/office/powerpoint/2010/main" val="1024086991"/>
-      </p:ext>
-    </p:extLst>
-  </p:cSld>
-  <p:clrMapOvr>
+        </ns0:txBody>
+      </ns0:sp>
+    </ns0:spTree>
+    <ns0:extLst>
+      <ns0:ext uri="{BB962C8B-B14F-4D97-AF65-F5344CB8AC3E}">
+        <ns2:creationId val="1024086991"/>
+      </ns0:ext>
+    </ns0:extLst>
+  </ns0:cSld>
+  <ns0:clrMapOvr>
     <a:masterClrMapping/>
-  </p:clrMapOvr>
-</p:notes>
+  </ns0:clrMapOvr>
+</ns0:notes>
 </file>
 
 <file path=ppt/notesSlides/notesSlide8.xml><?xml version="1.0" encoding="utf-8"?>
-<p:notes xmlns:a="http://schemas.openxmlformats.org/drawingml/2006/main" xmlns:r="http://schemas.openxmlformats.org/officeDocument/2006/relationships" xmlns:p="http://schemas.openxmlformats.org/presentationml/2006/main">
-  <p:cSld>
-    <p:spTree>
-      <p:nvGrpSpPr>
-        <p:cNvPr id="1" name=""/>
-        <p:cNvGrpSpPr/>
-        <p:nvPr/>
-      </p:nvGrpSpPr>
-      <p:grpSpPr>
+<ns0:notes xmlns:a="http://schemas.openxmlformats.org/drawingml/2006/main" xmlns:ns0="http://schemas.openxmlformats.org/presentationml/2006/main" xmlns:ns2="http://schemas.microsoft.com/office/powerpoint/2010/main">
+  <ns0:cSld>
+    <ns0:spTree>
+      <ns0:nvGrpSpPr>
+        <ns0:cNvPr id="1" name=""/>
+        <ns0:cNvGrpSpPr/>
+        <ns0:nvPr/>
+      </ns0:nvGrpSpPr>
+      <ns0:grpSpPr>
         <a:xfrm>
           <a:off x="0" y="0"/>
           <a:ext cx="0" cy="0"/>
           <a:chOff x="0" y="0"/>
           <a:chExt cx="0" cy="0"/>
         </a:xfrm>
-      </p:grpSpPr>
-      <p:sp>
-        <p:nvSpPr>
-          <p:cNvPr id="2" name="Slide Image Placeholder 1"/>
-          <p:cNvSpPr>
+      </ns0:grpSpPr>
+      <ns0:sp>
+        <ns0:nvSpPr>
+          <ns0:cNvPr id="2" name="Slide Image Placeholder 1"/>
+          <ns0:cNvSpPr>
             <a:spLocks noGrp="1" noRot="1" noChangeAspect="1"/>
-          </p:cNvSpPr>
-          <p:nvPr>
-            <p:ph type="sldImg"/>
-          </p:nvPr>
-        </p:nvSpPr>
-        <p:spPr/>
-      </p:sp>
-      <p:sp>
-        <p:nvSpPr>
-          <p:cNvPr id="3" name="Notes Placeholder 2"/>
-          <p:cNvSpPr>
+          </ns0:cNvSpPr>
+          <ns0:nvPr>
+            <ns0:ph type="sldImg"/>
+          </ns0:nvPr>
+        </ns0:nvSpPr>
+        <ns0:spPr/>
+      </ns0:sp>
+      <ns0:sp>
+        <ns0:nvSpPr>
+          <ns0:cNvPr id="3" name="Notes Placeholder 2"/>
+          <ns0:cNvSpPr>
             <a:spLocks noGrp="1"/>
-          </p:cNvSpPr>
-          <p:nvPr>
-            <p:ph type="body" idx="1"/>
-          </p:nvPr>
-        </p:nvSpPr>
-        <p:spPr/>
-        <p:txBody>
+          </ns0:cNvSpPr>
+          <ns0:nvPr>
+            <ns0:ph type="body" idx="1"/>
+          </ns0:nvPr>
+        </ns0:nvSpPr>
+        <ns0:spPr/>
+        <ns0:txBody>
           <a:bodyPr/>
           <a:lstStyle/>
           <a:p>
             <a:r>
               <a:rPr lang="en-US" dirty="0"/>
-              <a:t>1. Berechnen Sie f(2) für f(x)=x³−2x.
-Lösung: f(2)=8−4=4.
-2. Bestimmen Sie die Nullstellen von g(x)=x²−4.
-Lösung: x=−2 und x=2.
-3. Beschreiben Sie die Verschiebung von y=x² zu h(x)=(x−2)²+1.
-Lösung: Der Graph wird um 2 nach rechts und um 1 nach oben verschoben.
-4. Begründen Sie, dass x=0 eine Nullstelle von p(x)=x³−4x ist.
-Lösung: p(0)=0; daher ist x=0 eine Nullstelle.
-5. Skizzieren Sie den Graphen von f(x)=x² und markieren Sie Scheitelpunkt und Symmetrieachse.
-Lösung: Nach oben geöffnete Parabel mit S(0|0) und Symmetrieachse x=0.</a:t>
+              <a:t/>
             </a:r>
             <a:endParaRPr lang="en-US" dirty="0"/>
           </a:p>
-        </p:txBody>
-      </p:sp>
-      <p:sp>
-        <p:nvSpPr>
-          <p:cNvPr id="4" name="Slide Number Placeholder 3"/>
-          <p:cNvSpPr>
+        </ns0:txBody>
+      </ns0:sp>
+      <ns0:sp>
+        <ns0:nvSpPr>
+          <ns0:cNvPr id="4" name="Slide Number Placeholder 3"/>
+          <ns0:cNvSpPr>
             <a:spLocks noGrp="1"/>
-          </p:cNvSpPr>
-          <p:nvPr>
-            <p:ph type="sldNum" sz="quarter" idx="10"/>
-          </p:nvPr>
-        </p:nvSpPr>
-        <p:spPr/>
-        <p:txBody>
+          </ns0:cNvSpPr>
+          <ns0:nvPr>
+            <ns0:ph type="sldNum" sz="quarter" idx="10"/>
+          </ns0:nvPr>
+        </ns0:nvSpPr>
+        <ns0:spPr/>
+        <ns0:txBody>
           <a:bodyPr/>
           <a:lstStyle/>
           <a:p>
             <a:fld id="{F7021451-1387-4CA6-816F-3879F97B5CBC}" type="slidenum">
               <a:rPr lang="en-US"/>
-              <a:t>8</a:t>
+              <a:t/>
             </a:fld>
             <a:endParaRPr lang="en-US"/>
           </a:p>
-        </p:txBody>
-      </p:sp>
-    </p:spTree>
-    <p:extLst>
-      <p:ext uri="{BB962C8B-B14F-4D97-AF65-F5344CB8AC3E}">
-        <p14:creationId xmlns:p14="http://schemas.microsoft.com/office/powerpoint/2010/main" val="1024086991"/>
-      </p:ext>
-    </p:extLst>
-  </p:cSld>
-  <p:clrMapOvr>
+        </ns0:txBody>
+      </ns0:sp>
+    </ns0:spTree>
+    <ns0:extLst>
+      <ns0:ext uri="{BB962C8B-B14F-4D97-AF65-F5344CB8AC3E}">
+        <ns2:creationId val="1024086991"/>
+      </ns0:ext>
+    </ns0:extLst>
+  </ns0:cSld>
+  <ns0:clrMapOvr>
     <a:masterClrMapping/>
-  </p:clrMapOvr>
-</p:notes>
+  </ns0:clrMapOvr>
+</ns0:notes>
 </file>
 
 <file path=ppt/slideLayouts/slideLayout1.xml><?xml version="1.0" encoding="utf-8"?>
@@ -2765,29 +2726,29 @@
 </file>
 
 <file path=ppt/slides/slide2.xml><?xml version="1.0" encoding="utf-8"?>
-<p:sld xmlns:a="http://schemas.openxmlformats.org/drawingml/2006/main" xmlns:r="http://schemas.openxmlformats.org/officeDocument/2006/relationships" xmlns:p="http://schemas.openxmlformats.org/presentationml/2006/main">
-  <p:cSld name="Slide 2">
-    <p:spTree>
-      <p:nvGrpSpPr>
-        <p:cNvPr id="1" name=""/>
-        <p:cNvGrpSpPr/>
-        <p:nvPr/>
-      </p:nvGrpSpPr>
-      <p:grpSpPr>
+<ns0:sld xmlns:a="http://schemas.openxmlformats.org/drawingml/2006/main" xmlns:ns0="http://schemas.openxmlformats.org/presentationml/2006/main" xmlns:ns2="http://schemas.microsoft.com/office/mac/drawingml/2011/main">
+  <ns0:cSld name="Slide 2">
+    <ns0:spTree>
+      <ns0:nvGrpSpPr>
+        <ns0:cNvPr id="1" name=""/>
+        <ns0:cNvGrpSpPr/>
+        <ns0:nvPr/>
+      </ns0:nvGrpSpPr>
+      <ns0:grpSpPr>
         <a:xfrm>
           <a:off x="0" y="0"/>
           <a:ext cx="0" cy="0"/>
           <a:chOff x="0" y="0"/>
           <a:chExt cx="0" cy="0"/>
         </a:xfrm>
-      </p:grpSpPr>
-      <p:sp>
-        <p:nvSpPr>
-          <p:cNvPr id="2" name="Text 0"/>
-          <p:cNvSpPr/>
-          <p:nvPr/>
-        </p:nvSpPr>
-        <p:spPr>
+      </ns0:grpSpPr>
+      <ns0:sp>
+        <ns0:nvSpPr>
+          <ns0:cNvPr id="2" name="Text 0"/>
+          <ns0:cNvSpPr/>
+          <ns0:nvPr/>
+        </ns0:nvSpPr>
+        <ns0:spPr>
           <a:xfrm>
             <a:off x="658368" y="658368"/>
             <a:ext cx="9784080" cy="475488"/>
@@ -2797,8 +2758,8 @@
           </a:prstGeom>
           <a:noFill/>
           <a:ln/>
-        </p:spPr>
-        <p:txBody>
+        </ns0:spPr>
+        <ns0:txBody>
           <a:bodyPr wrap="square" lIns="508" tIns="508" rIns="508" bIns="508" rtlCol="0" anchor="ctr">
             <a:normAutofit/>
           </a:bodyPr>
@@ -2820,15 +2781,15 @@
             </a:r>
             <a:endParaRPr lang="en-US" sz="2600" dirty="0"/>
           </a:p>
-        </p:txBody>
-      </p:sp>
-      <p:sp>
-        <p:nvSpPr>
-          <p:cNvPr id="3" name="Shape 1"/>
-          <p:cNvSpPr/>
-          <p:nvPr/>
-        </p:nvSpPr>
-        <p:spPr>
+        </ns0:txBody>
+      </ns0:sp>
+      <ns0:sp>
+        <ns0:nvSpPr>
+          <ns0:cNvPr id="3" name="Shape 1"/>
+          <ns0:cNvSpPr/>
+          <ns0:nvPr/>
+        </ns0:nvSpPr>
+        <ns0:spPr>
           <a:xfrm>
             <a:off x="10744200" y="694944"/>
             <a:ext cx="685800" cy="109728"/>
@@ -2845,15 +2806,15 @@
             </a:solidFill>
             <a:prstDash val="solid"/>
           </a:ln>
-        </p:spPr>
-      </p:sp>
-      <p:sp>
-        <p:nvSpPr>
-          <p:cNvPr id="4" name="Text 2"/>
-          <p:cNvSpPr/>
-          <p:nvPr/>
-        </p:nvSpPr>
-        <p:spPr>
+        </ns0:spPr>
+      </ns0:sp>
+      <ns0:sp>
+        <ns0:nvSpPr>
+          <ns0:cNvPr id="4" name="Text 2"/>
+          <ns0:cNvSpPr/>
+          <ns0:nvPr/>
+        </ns0:nvSpPr>
+        <ns0:spPr>
           <a:xfrm>
             <a:off x="676656" y="1152144"/>
             <a:ext cx="7772400" cy="256032"/>
@@ -2863,8 +2824,8 @@
           </a:prstGeom>
           <a:noFill/>
           <a:ln/>
-        </p:spPr>
-        <p:txBody>
+        </ns0:spPr>
+        <ns0:txBody>
           <a:bodyPr wrap="square" lIns="508" tIns="508" rIns="508" bIns="508" rtlCol="0" anchor="ctr">
             <a:normAutofit/>
           </a:bodyPr>
@@ -2886,15 +2847,15 @@
             </a:r>
             <a:endParaRPr lang="en-US" sz="1150" dirty="0"/>
           </a:p>
-        </p:txBody>
-      </p:sp>
-      <p:sp>
-        <p:nvSpPr>
-          <p:cNvPr id="5" name="Shape 3"/>
-          <p:cNvSpPr/>
-          <p:nvPr/>
-        </p:nvSpPr>
-        <p:spPr>
+        </ns0:txBody>
+      </ns0:sp>
+      <ns0:sp>
+        <ns0:nvSpPr>
+          <ns0:cNvPr id="5" name="Shape 3"/>
+          <ns0:cNvSpPr/>
+          <ns0:nvPr/>
+        </ns0:nvSpPr>
+        <ns0:spPr>
           <a:xfrm>
             <a:off x="731520" y="1600200"/>
             <a:ext cx="5257800" cy="1600200"/>
@@ -2920,15 +2881,15 @@
               </a:srgbClr>
             </a:outerShdw>
           </a:effectLst>
-        </p:spPr>
-      </p:sp>
-      <p:sp>
-        <p:nvSpPr>
-          <p:cNvPr id="6" name="Shape 4"/>
-          <p:cNvSpPr/>
-          <p:nvPr/>
-        </p:nvSpPr>
-        <p:spPr>
+        </ns0:spPr>
+      </ns0:sp>
+      <ns0:sp>
+        <ns0:nvSpPr>
+          <ns0:cNvPr id="6" name="Shape 4"/>
+          <ns0:cNvSpPr/>
+          <ns0:nvPr/>
+        </ns0:nvSpPr>
+        <ns0:spPr>
           <a:xfrm>
             <a:off x="896112" y="1764792"/>
             <a:ext cx="438912" cy="438912"/>
@@ -2945,15 +2906,15 @@
             </a:solidFill>
             <a:prstDash val="solid"/>
           </a:ln>
-        </p:spPr>
-      </p:sp>
-      <p:sp>
-        <p:nvSpPr>
-          <p:cNvPr id="7" name="Text 5"/>
-          <p:cNvSpPr/>
-          <p:nvPr/>
-        </p:nvSpPr>
-        <p:spPr>
+        </ns0:spPr>
+      </ns0:sp>
+      <ns0:sp>
+        <ns0:nvSpPr>
+          <ns0:cNvPr id="7" name="Text 5"/>
+          <ns0:cNvSpPr/>
+          <ns0:nvPr/>
+        </ns0:nvSpPr>
+        <ns0:spPr>
           <a:xfrm>
             <a:off x="896112" y="1764792"/>
             <a:ext cx="438912" cy="438912"/>
@@ -2963,8 +2924,8 @@
           </a:prstGeom>
           <a:noFill/>
           <a:ln/>
-        </p:spPr>
-        <p:txBody>
+        </ns0:spPr>
+        <ns0:txBody>
           <a:bodyPr wrap="square" lIns="508" tIns="508" rIns="508" bIns="508" rtlCol="0" anchor="ctr">
             <a:normAutofit/>
           </a:bodyPr>
@@ -2986,15 +2947,15 @@
             </a:r>
             <a:endParaRPr lang="en-US" sz="1300" dirty="0"/>
           </a:p>
-        </p:txBody>
-      </p:sp>
-      <p:sp>
-        <p:nvSpPr>
-          <p:cNvPr id="8" name="Text 6"/>
-          <p:cNvSpPr/>
-          <p:nvPr/>
-        </p:nvSpPr>
-        <p:spPr>
+        </ns0:txBody>
+      </ns0:sp>
+      <ns0:sp>
+        <ns0:nvSpPr>
+          <ns0:cNvPr id="8" name="Text 6"/>
+          <ns0:cNvSpPr/>
+          <ns0:nvPr/>
+        </ns0:nvSpPr>
+        <ns0:spPr>
           <a:xfrm>
             <a:off x="1463040" y="1755648"/>
             <a:ext cx="4361688" cy="1344168"/>
@@ -3004,8 +2965,8 @@
           </a:prstGeom>
           <a:noFill/>
           <a:ln/>
-        </p:spPr>
-        <p:txBody>
+        </ns0:spPr>
+        <ns0:txBody>
           <a:bodyPr wrap="square" lIns="508" tIns="508" rIns="508" bIns="508" rtlCol="0" anchor="ctr">
             <a:normAutofit/>
           </a:bodyPr>
@@ -3027,15 +2988,15 @@
             </a:r>
             <a:endParaRPr lang="en-US" sz="1650" dirty="0"/>
           </a:p>
-        </p:txBody>
-      </p:sp>
-      <p:sp>
-        <p:nvSpPr>
-          <p:cNvPr id="9" name="Shape 7"/>
-          <p:cNvSpPr/>
-          <p:nvPr/>
-        </p:nvSpPr>
-        <p:spPr>
+        </ns0:txBody>
+      </ns0:sp>
+      <ns0:sp>
+        <ns0:nvSpPr>
+          <ns0:cNvPr id="9" name="Shape 7"/>
+          <ns0:cNvSpPr/>
+          <ns0:nvPr/>
+        </ns0:nvSpPr>
+        <ns0:spPr>
           <a:xfrm>
             <a:off x="6199632" y="1600200"/>
             <a:ext cx="5257800" cy="1600200"/>
@@ -3061,15 +3022,15 @@
               </a:srgbClr>
             </a:outerShdw>
           </a:effectLst>
-        </p:spPr>
-      </p:sp>
-      <p:sp>
-        <p:nvSpPr>
-          <p:cNvPr id="10" name="Shape 8"/>
-          <p:cNvSpPr/>
-          <p:nvPr/>
-        </p:nvSpPr>
-        <p:spPr>
+        </ns0:spPr>
+      </ns0:sp>
+      <ns0:sp>
+        <ns0:nvSpPr>
+          <ns0:cNvPr id="10" name="Shape 8"/>
+          <ns0:cNvSpPr/>
+          <ns0:nvPr/>
+        </ns0:nvSpPr>
+        <ns0:spPr>
           <a:xfrm>
             <a:off x="6364224" y="1764792"/>
             <a:ext cx="438912" cy="438912"/>
@@ -3086,15 +3047,15 @@
             </a:solidFill>
             <a:prstDash val="solid"/>
           </a:ln>
-        </p:spPr>
-      </p:sp>
-      <p:sp>
-        <p:nvSpPr>
-          <p:cNvPr id="11" name="Text 9"/>
-          <p:cNvSpPr/>
-          <p:nvPr/>
-        </p:nvSpPr>
-        <p:spPr>
+        </ns0:spPr>
+      </ns0:sp>
+      <ns0:sp>
+        <ns0:nvSpPr>
+          <ns0:cNvPr id="11" name="Text 9"/>
+          <ns0:cNvSpPr/>
+          <ns0:nvPr/>
+        </ns0:nvSpPr>
+        <ns0:spPr>
           <a:xfrm>
             <a:off x="6364224" y="1764792"/>
             <a:ext cx="438912" cy="438912"/>
@@ -3104,8 +3065,8 @@
           </a:prstGeom>
           <a:noFill/>
           <a:ln/>
-        </p:spPr>
-        <p:txBody>
+        </ns0:spPr>
+        <ns0:txBody>
           <a:bodyPr wrap="square" lIns="508" tIns="508" rIns="508" bIns="508" rtlCol="0" anchor="ctr">
             <a:normAutofit/>
           </a:bodyPr>
@@ -3127,15 +3088,15 @@
             </a:r>
             <a:endParaRPr lang="en-US" sz="1300" dirty="0"/>
           </a:p>
-        </p:txBody>
-      </p:sp>
-      <p:sp>
-        <p:nvSpPr>
-          <p:cNvPr id="12" name="Text 10"/>
-          <p:cNvSpPr/>
-          <p:nvPr/>
-        </p:nvSpPr>
-        <p:spPr>
+        </ns0:txBody>
+      </ns0:sp>
+      <ns0:sp>
+        <ns0:nvSpPr>
+          <ns0:cNvPr id="12" name="Text 10"/>
+          <ns0:cNvSpPr/>
+          <ns0:nvPr/>
+        </ns0:nvSpPr>
+        <ns0:spPr>
           <a:xfrm>
             <a:off x="6931152" y="1755648"/>
             <a:ext cx="4361688" cy="1344168"/>
@@ -3145,8 +3106,8 @@
           </a:prstGeom>
           <a:noFill/>
           <a:ln/>
-        </p:spPr>
-        <p:txBody>
+        </ns0:spPr>
+        <ns0:txBody>
           <a:bodyPr wrap="square" lIns="508" tIns="508" rIns="508" bIns="508" rtlCol="0" anchor="ctr">
             <a:normAutofit/>
           </a:bodyPr>
@@ -3168,15 +3129,15 @@
             </a:r>
             <a:endParaRPr lang="en-US" sz="1650" dirty="0"/>
           </a:p>
-        </p:txBody>
-      </p:sp>
-      <p:sp>
-        <p:nvSpPr>
-          <p:cNvPr id="13" name="Shape 11"/>
-          <p:cNvSpPr/>
-          <p:nvPr/>
-        </p:nvSpPr>
-        <p:spPr>
+        </ns0:txBody>
+      </ns0:sp>
+      <ns0:sp>
+        <ns0:nvSpPr>
+          <ns0:cNvPr id="13" name="Shape 11"/>
+          <ns0:cNvSpPr/>
+          <ns0:nvPr/>
+        </ns0:nvSpPr>
+        <ns0:spPr>
           <a:xfrm>
             <a:off x="731520" y="3456432"/>
             <a:ext cx="5257800" cy="1600200"/>
@@ -3202,15 +3163,15 @@
               </a:srgbClr>
             </a:outerShdw>
           </a:effectLst>
-        </p:spPr>
-      </p:sp>
-      <p:sp>
-        <p:nvSpPr>
-          <p:cNvPr id="14" name="Shape 12"/>
-          <p:cNvSpPr/>
-          <p:nvPr/>
-        </p:nvSpPr>
-        <p:spPr>
+        </ns0:spPr>
+      </ns0:sp>
+      <ns0:sp>
+        <ns0:nvSpPr>
+          <ns0:cNvPr id="14" name="Shape 12"/>
+          <ns0:cNvSpPr/>
+          <ns0:nvPr/>
+        </ns0:nvSpPr>
+        <ns0:spPr>
           <a:xfrm>
             <a:off x="896112" y="3621024"/>
             <a:ext cx="438912" cy="438912"/>
@@ -3227,15 +3188,15 @@
             </a:solidFill>
             <a:prstDash val="solid"/>
           </a:ln>
-        </p:spPr>
-      </p:sp>
-      <p:sp>
-        <p:nvSpPr>
-          <p:cNvPr id="15" name="Text 13"/>
-          <p:cNvSpPr/>
-          <p:nvPr/>
-        </p:nvSpPr>
-        <p:spPr>
+        </ns0:spPr>
+      </ns0:sp>
+      <ns0:sp>
+        <ns0:nvSpPr>
+          <ns0:cNvPr id="15" name="Text 13"/>
+          <ns0:cNvSpPr/>
+          <ns0:nvPr/>
+        </ns0:nvSpPr>
+        <ns0:spPr>
           <a:xfrm>
             <a:off x="896112" y="3621024"/>
             <a:ext cx="438912" cy="438912"/>
@@ -3245,8 +3206,8 @@
           </a:prstGeom>
           <a:noFill/>
           <a:ln/>
-        </p:spPr>
-        <p:txBody>
+        </ns0:spPr>
+        <ns0:txBody>
           <a:bodyPr wrap="square" lIns="508" tIns="508" rIns="508" bIns="508" rtlCol="0" anchor="ctr">
             <a:normAutofit/>
           </a:bodyPr>
@@ -3268,15 +3229,15 @@
             </a:r>
             <a:endParaRPr lang="en-US" sz="1300" dirty="0"/>
           </a:p>
-        </p:txBody>
-      </p:sp>
-      <p:sp>
-        <p:nvSpPr>
-          <p:cNvPr id="16" name="Text 14"/>
-          <p:cNvSpPr/>
-          <p:nvPr/>
-        </p:nvSpPr>
-        <p:spPr>
+        </ns0:txBody>
+      </ns0:sp>
+      <ns0:sp>
+        <ns0:nvSpPr>
+          <ns0:cNvPr id="16" name="Text 14"/>
+          <ns0:cNvSpPr/>
+          <ns0:nvPr/>
+        </ns0:nvSpPr>
+        <ns0:spPr>
           <a:xfrm>
             <a:off x="1463040" y="3611880"/>
             <a:ext cx="4361688" cy="1344168"/>
@@ -3286,8 +3247,8 @@
           </a:prstGeom>
           <a:noFill/>
           <a:ln/>
-        </p:spPr>
-        <p:txBody>
+        </ns0:spPr>
+        <ns0:txBody>
           <a:bodyPr wrap="square" lIns="508" tIns="508" rIns="508" bIns="508" rtlCol="0" anchor="ctr">
             <a:normAutofit/>
           </a:bodyPr>
@@ -3309,15 +3270,15 @@
             </a:r>
             <a:endParaRPr lang="en-US" sz="1650" dirty="0"/>
           </a:p>
-        </p:txBody>
-      </p:sp>
-      <p:sp>
-        <p:nvSpPr>
-          <p:cNvPr id="17" name="Shape 15"/>
-          <p:cNvSpPr/>
-          <p:nvPr/>
-        </p:nvSpPr>
-        <p:spPr>
+        </ns0:txBody>
+      </ns0:sp>
+      <ns0:sp>
+        <ns0:nvSpPr>
+          <ns0:cNvPr id="17" name="Shape 15"/>
+          <ns0:cNvSpPr/>
+          <ns0:nvPr/>
+        </ns0:nvSpPr>
+        <ns0:spPr>
           <a:xfrm>
             <a:off x="6199632" y="3456432"/>
             <a:ext cx="5257800" cy="1600200"/>
@@ -3343,15 +3304,15 @@
               </a:srgbClr>
             </a:outerShdw>
           </a:effectLst>
-        </p:spPr>
-      </p:sp>
-      <p:sp>
-        <p:nvSpPr>
-          <p:cNvPr id="18" name="Shape 16"/>
-          <p:cNvSpPr/>
-          <p:nvPr/>
-        </p:nvSpPr>
-        <p:spPr>
+        </ns0:spPr>
+      </ns0:sp>
+      <ns0:sp>
+        <ns0:nvSpPr>
+          <ns0:cNvPr id="18" name="Shape 16"/>
+          <ns0:cNvSpPr/>
+          <ns0:nvPr/>
+        </ns0:nvSpPr>
+        <ns0:spPr>
           <a:xfrm>
             <a:off x="6364224" y="3621024"/>
             <a:ext cx="438912" cy="438912"/>
@@ -3368,15 +3329,15 @@
             </a:solidFill>
             <a:prstDash val="solid"/>
           </a:ln>
-        </p:spPr>
-      </p:sp>
-      <p:sp>
-        <p:nvSpPr>
-          <p:cNvPr id="19" name="Text 17"/>
-          <p:cNvSpPr/>
-          <p:nvPr/>
-        </p:nvSpPr>
-        <p:spPr>
+        </ns0:spPr>
+      </ns0:sp>
+      <ns0:sp>
+        <ns0:nvSpPr>
+          <ns0:cNvPr id="19" name="Text 17"/>
+          <ns0:cNvSpPr/>
+          <ns0:nvPr/>
+        </ns0:nvSpPr>
+        <ns0:spPr>
           <a:xfrm>
             <a:off x="6364224" y="3621024"/>
             <a:ext cx="438912" cy="438912"/>
@@ -3386,8 +3347,8 @@
           </a:prstGeom>
           <a:noFill/>
           <a:ln/>
-        </p:spPr>
-        <p:txBody>
+        </ns0:spPr>
+        <ns0:txBody>
           <a:bodyPr wrap="square" lIns="508" tIns="508" rIns="508" bIns="508" rtlCol="0" anchor="ctr">
             <a:normAutofit/>
           </a:bodyPr>
@@ -3409,15 +3370,15 @@
             </a:r>
             <a:endParaRPr lang="en-US" sz="1300" dirty="0"/>
           </a:p>
-        </p:txBody>
-      </p:sp>
-      <p:sp>
-        <p:nvSpPr>
-          <p:cNvPr id="20" name="Text 18"/>
-          <p:cNvSpPr/>
-          <p:nvPr/>
-        </p:nvSpPr>
-        <p:spPr>
+        </ns0:txBody>
+      </ns0:sp>
+      <ns0:sp>
+        <ns0:nvSpPr>
+          <ns0:cNvPr id="20" name="Text 18"/>
+          <ns0:cNvSpPr/>
+          <ns0:nvPr/>
+        </ns0:nvSpPr>
+        <ns0:spPr>
           <a:xfrm>
             <a:off x="6931152" y="3611880"/>
             <a:ext cx="4361688" cy="1344168"/>
@@ -3427,8 +3388,8 @@
           </a:prstGeom>
           <a:noFill/>
           <a:ln/>
-        </p:spPr>
-        <p:txBody>
+        </ns0:spPr>
+        <ns0:txBody>
           <a:bodyPr wrap="square" lIns="508" tIns="508" rIns="508" bIns="508" rtlCol="0" anchor="ctr">
             <a:normAutofit/>
           </a:bodyPr>
@@ -3450,15 +3411,15 @@
             </a:r>
             <a:endParaRPr lang="en-US" sz="1650" dirty="0"/>
           </a:p>
-        </p:txBody>
-      </p:sp>
-      <p:sp>
-        <p:nvSpPr>
-          <p:cNvPr id="21" name="Text 19"/>
-          <p:cNvSpPr/>
-          <p:nvPr/>
-        </p:nvSpPr>
-        <p:spPr>
+        </ns0:txBody>
+      </ns0:sp>
+      <ns0:sp>
+        <ns0:nvSpPr>
+          <ns0:cNvPr id="21" name="Text 19"/>
+          <ns0:cNvSpPr/>
+          <ns0:nvPr/>
+        </ns0:nvSpPr>
+        <ns0:spPr>
           <a:xfrm>
             <a:off x="749808" y="5532120"/>
             <a:ext cx="4754880" cy="274320"/>
@@ -3468,8 +3429,8 @@
           </a:prstGeom>
           <a:noFill/>
           <a:ln/>
-        </p:spPr>
-        <p:txBody>
+        </ns0:spPr>
+        <ns0:txBody>
           <a:bodyPr wrap="square" lIns="508" tIns="508" rIns="508" bIns="508" rtlCol="0" anchor="ctr">
             <a:normAutofit/>
           </a:bodyPr>
@@ -3487,23 +3448,23 @@
                 <a:ea typeface="Arial" pitchFamily="34" charset="-122"/>
                 <a:cs typeface="Arial" pitchFamily="34" charset="-120"/>
               </a:rPr>
-              <a:t>Ziel: erst Sicherheit gewinnen – dann steigern.</a:t>
+              <a:t/>
             </a:r>
             <a:endParaRPr lang="en-US" sz="1150" dirty="0"/>
           </a:p>
-        </p:txBody>
-      </p:sp>
-      <p:sp>
-        <p:nvSpPr>
-          <p:cNvPr id="25" name="Slide Number Placeholder 0"/>
-          <p:cNvSpPr>
+        </ns0:txBody>
+      </ns0:sp>
+      <ns0:sp>
+        <ns0:nvSpPr>
+          <ns0:cNvPr id="25" name="Slide Number Placeholder 0"/>
+          <ns0:cNvSpPr>
             <a:spLocks noGrp="1"/>
-          </p:cNvSpPr>
-          <p:nvPr>
-            <p:ph type="sldNum" sz="quarter" idx="4294967295"/>
-          </p:nvPr>
-        </p:nvSpPr>
-        <p:spPr>
+          </ns0:cNvSpPr>
+          <ns0:nvPr>
+            <ns0:ph type="sldNum" sz="quarter" idx="4294967295"/>
+          </ns0:nvPr>
+        </ns0:nvSpPr>
+        <ns0:spPr>
           <a:xfrm>
             <a:off x="11384280" y="6492240"/>
             <a:ext cx="320040" cy="164592"/>
@@ -3513,11 +3474,11 @@
           </a:prstGeom>
           <a:extLst>
             <a:ext uri="{C572A759-6A51-4108-AA02-DFA0A04FC94B}">
-              <ma14:wrappingTextBoxFlag xmlns:ma14="http://schemas.microsoft.com/office/mac/drawingml/2011/main" val="0"/>
+              <ns2:wrappingTextBoxFlag val="0"/>
             </a:ext>
           </a:extLst>
-        </p:spPr>
-        <p:txBody>
+        </ns0:spPr>
+        <ns0:txBody>
           <a:bodyPr/>
           <a:lstStyle>
             <a:lvl1pPr>
@@ -3539,14 +3500,14 @@
             </a:fld>
             <a:endParaRPr lang="en-US"/>
           </a:p>
-        </p:txBody>
-      </p:sp>
-    </p:spTree>
-  </p:cSld>
-  <p:clrMapOvr>
+        </ns0:txBody>
+      </ns0:sp>
+    </ns0:spTree>
+  </ns0:cSld>
+  <ns0:clrMapOvr>
     <a:masterClrMapping/>
-  </p:clrMapOvr>
-</p:sld>
+  </ns0:clrMapOvr>
+</ns0:sld>
 </file>
 
 <file path=ppt/slides/slide3.xml><?xml version="1.0" encoding="utf-8"?>
@@ -8858,29 +8819,29 @@
 </file>
 
 <file path=ppt/slides/slide8.xml><?xml version="1.0" encoding="utf-8"?>
-<p:sld xmlns:a="http://schemas.openxmlformats.org/drawingml/2006/main" xmlns:r="http://schemas.openxmlformats.org/officeDocument/2006/relationships" xmlns:p="http://schemas.openxmlformats.org/presentationml/2006/main">
-  <p:cSld name="Slide 8">
-    <p:spTree>
-      <p:nvGrpSpPr>
-        <p:cNvPr id="1" name=""/>
-        <p:cNvGrpSpPr/>
-        <p:nvPr/>
-      </p:nvGrpSpPr>
-      <p:grpSpPr>
+<ns0:sld xmlns:a="http://schemas.openxmlformats.org/drawingml/2006/main" xmlns:ns0="http://schemas.openxmlformats.org/presentationml/2006/main" xmlns:ns2="http://schemas.microsoft.com/office/mac/drawingml/2011/main">
+  <ns0:cSld name="Slide 8">
+    <ns0:spTree>
+      <ns0:nvGrpSpPr>
+        <ns0:cNvPr id="1" name=""/>
+        <ns0:cNvGrpSpPr/>
+        <ns0:nvPr/>
+      </ns0:nvGrpSpPr>
+      <ns0:grpSpPr>
         <a:xfrm>
           <a:off x="0" y="0"/>
           <a:ext cx="0" cy="0"/>
           <a:chOff x="0" y="0"/>
           <a:chExt cx="0" cy="0"/>
         </a:xfrm>
-      </p:grpSpPr>
-      <p:sp>
-        <p:nvSpPr>
-          <p:cNvPr id="2" name="Text 0"/>
-          <p:cNvSpPr/>
-          <p:nvPr/>
-        </p:nvSpPr>
-        <p:spPr>
+      </ns0:grpSpPr>
+      <ns0:sp>
+        <ns0:nvSpPr>
+          <ns0:cNvPr id="2" name="Text 0"/>
+          <ns0:cNvSpPr/>
+          <ns0:nvPr/>
+        </ns0:nvSpPr>
+        <ns0:spPr>
           <a:xfrm>
             <a:off x="685800" y="1207008"/>
             <a:ext cx="7680960" cy="512064"/>
@@ -8890,8 +8851,8 @@
           </a:prstGeom>
           <a:noFill/>
           <a:ln/>
-        </p:spPr>
-        <p:txBody>
+        </ns0:spPr>
+        <ns0:txBody>
           <a:bodyPr wrap="square" lIns="508" tIns="508" rIns="508" bIns="508" rtlCol="0" anchor="ctr">
             <a:normAutofit/>
           </a:bodyPr>
@@ -8909,19 +8870,19 @@
                 <a:ea typeface="Arial" pitchFamily="34" charset="-122"/>
                 <a:cs typeface="Arial" pitchFamily="34" charset="-120"/>
               </a:rPr>
-              <a:t>Kontrollfragen im Abiturstil</a:t>
+              <a:t>Kontrollfragen</a:t>
             </a:r>
             <a:endParaRPr lang="en-US" sz="2700" dirty="0"/>
           </a:p>
-        </p:txBody>
-      </p:sp>
-      <p:sp>
-        <p:nvSpPr>
-          <p:cNvPr id="3" name="Text 1"/>
-          <p:cNvSpPr/>
-          <p:nvPr/>
-        </p:nvSpPr>
-        <p:spPr>
+        </ns0:txBody>
+      </ns0:sp>
+      <ns0:sp>
+        <ns0:nvSpPr>
+          <ns0:cNvPr id="3" name="Text 1"/>
+          <ns0:cNvSpPr/>
+          <ns0:nvPr/>
+        </ns0:nvSpPr>
+        <ns0:spPr>
           <a:xfrm>
             <a:off x="713232" y="1737360"/>
             <a:ext cx="10424160" cy="256032"/>
@@ -8931,8 +8892,8 @@
           </a:prstGeom>
           <a:noFill/>
           <a:ln/>
-        </p:spPr>
-        <p:txBody>
+        </ns0:spPr>
+        <ns0:txBody>
           <a:bodyPr wrap="square" lIns="508" tIns="508" rIns="508" bIns="508" rtlCol="0" anchor="ctr">
             <a:normAutofit/>
           </a:bodyPr>
@@ -8950,19 +8911,19 @@
                 <a:ea typeface="Arial" pitchFamily="34" charset="-122"/>
                 <a:cs typeface="Arial" pitchFamily="34" charset="-120"/>
               </a:rPr>
-              <a:t>Einführungsphase (EF) · Funktionen und Analysis · Operatorensprache trainieren</a:t>
+              <a:t>Einführungsphase (EF) · Funktionen und Analysis</a:t>
             </a:r>
             <a:endParaRPr lang="en-US" sz="1250" dirty="0"/>
           </a:p>
-        </p:txBody>
-      </p:sp>
-      <p:sp>
-        <p:nvSpPr>
-          <p:cNvPr id="4" name="Shape 2"/>
-          <p:cNvSpPr/>
-          <p:nvPr/>
-        </p:nvSpPr>
-        <p:spPr>
+        </ns0:txBody>
+      </ns0:sp>
+      <ns0:sp>
+        <ns0:nvSpPr>
+          <ns0:cNvPr id="4" name="Shape 2"/>
+          <ns0:cNvSpPr/>
+          <ns0:nvPr/>
+        </ns0:nvSpPr>
+        <ns0:spPr>
           <a:xfrm>
             <a:off x="731520" y="2331720"/>
             <a:ext cx="5230368" cy="841248"/>
@@ -8981,15 +8942,15 @@
             </a:solidFill>
             <a:prstDash val="solid"/>
           </a:ln>
-        </p:spPr>
-      </p:sp>
-      <p:sp>
-        <p:nvSpPr>
-          <p:cNvPr id="5" name="Shape 3"/>
-          <p:cNvSpPr/>
-          <p:nvPr/>
-        </p:nvSpPr>
-        <p:spPr>
+        </ns0:spPr>
+      </ns0:sp>
+      <ns0:sp>
+        <ns0:nvSpPr>
+          <ns0:cNvPr id="5" name="Shape 3"/>
+          <ns0:cNvSpPr/>
+          <ns0:nvPr/>
+        </ns0:nvSpPr>
+        <ns0:spPr>
           <a:xfrm>
             <a:off x="859536" y="2496312"/>
             <a:ext cx="1170432" cy="274320"/>
@@ -9008,15 +8969,15 @@
             </a:solidFill>
             <a:prstDash val="solid"/>
           </a:ln>
-        </p:spPr>
-      </p:sp>
-      <p:sp>
-        <p:nvSpPr>
-          <p:cNvPr id="6" name="Text 4"/>
-          <p:cNvSpPr/>
-          <p:nvPr/>
-        </p:nvSpPr>
-        <p:spPr>
+        </ns0:spPr>
+      </ns0:sp>
+      <ns0:sp>
+        <ns0:nvSpPr>
+          <ns0:cNvPr id="6" name="Text 4"/>
+          <ns0:cNvSpPr/>
+          <ns0:nvPr/>
+        </ns0:nvSpPr>
+        <ns0:spPr>
           <a:xfrm>
             <a:off x="896112" y="2514600"/>
             <a:ext cx="1097280" cy="210312"/>
@@ -9026,8 +8987,8 @@
           </a:prstGeom>
           <a:noFill/>
           <a:ln/>
-        </p:spPr>
-        <p:txBody>
+        </ns0:spPr>
+        <ns0:txBody>
           <a:bodyPr wrap="square" lIns="508" tIns="508" rIns="508" bIns="508" rtlCol="0" anchor="ctr">
             <a:normAutofit/>
           </a:bodyPr>
@@ -9049,15 +9010,15 @@
             </a:r>
             <a:endParaRPr lang="en-US" sz="820" dirty="0"/>
           </a:p>
-        </p:txBody>
-      </p:sp>
-      <p:sp>
-        <p:nvSpPr>
-          <p:cNvPr id="7" name="Text 5"/>
-          <p:cNvSpPr/>
-          <p:nvPr/>
-        </p:nvSpPr>
-        <p:spPr>
+        </ns0:txBody>
+      </ns0:sp>
+      <ns0:sp>
+        <ns0:nvSpPr>
+          <ns0:cNvPr id="7" name="Text 5"/>
+          <ns0:cNvSpPr/>
+          <ns0:nvPr/>
+        </ns0:nvSpPr>
+        <ns0:spPr>
           <a:xfrm>
             <a:off x="2194560" y="2432304"/>
             <a:ext cx="3621024" cy="621792"/>
@@ -9067,8 +9028,8 @@
           </a:prstGeom>
           <a:noFill/>
           <a:ln/>
-        </p:spPr>
-        <p:txBody>
+        </ns0:spPr>
+        <ns0:txBody>
           <a:bodyPr wrap="square" lIns="508" tIns="508" rIns="508" bIns="508" rtlCol="0" anchor="ctr">
             <a:normAutofit/>
           </a:bodyPr>
@@ -9090,15 +9051,15 @@
             </a:r>
             <a:endParaRPr lang="en-US" sz="1230" dirty="0"/>
           </a:p>
-        </p:txBody>
-      </p:sp>
-      <p:sp>
-        <p:nvSpPr>
-          <p:cNvPr id="8" name="Shape 6"/>
-          <p:cNvSpPr/>
-          <p:nvPr/>
-        </p:nvSpPr>
-        <p:spPr>
+        </ns0:txBody>
+      </ns0:sp>
+      <ns0:sp>
+        <ns0:nvSpPr>
+          <ns0:cNvPr id="8" name="Shape 6"/>
+          <ns0:cNvSpPr/>
+          <ns0:nvPr/>
+        </ns0:nvSpPr>
+        <ns0:spPr>
           <a:xfrm>
             <a:off x="6236208" y="2331720"/>
             <a:ext cx="5230368" cy="841248"/>
@@ -9117,15 +9078,15 @@
             </a:solidFill>
             <a:prstDash val="solid"/>
           </a:ln>
-        </p:spPr>
-      </p:sp>
-      <p:sp>
-        <p:nvSpPr>
-          <p:cNvPr id="9" name="Shape 7"/>
-          <p:cNvSpPr/>
-          <p:nvPr/>
-        </p:nvSpPr>
-        <p:spPr>
+        </ns0:spPr>
+      </ns0:sp>
+      <ns0:sp>
+        <ns0:nvSpPr>
+          <ns0:cNvPr id="9" name="Shape 7"/>
+          <ns0:cNvSpPr/>
+          <ns0:nvPr/>
+        </ns0:nvSpPr>
+        <ns0:spPr>
           <a:xfrm>
             <a:off x="6364224" y="2496312"/>
             <a:ext cx="1170432" cy="274320"/>
@@ -9144,15 +9105,15 @@
             </a:solidFill>
             <a:prstDash val="solid"/>
           </a:ln>
-        </p:spPr>
-      </p:sp>
-      <p:sp>
-        <p:nvSpPr>
-          <p:cNvPr id="10" name="Text 8"/>
-          <p:cNvSpPr/>
-          <p:nvPr/>
-        </p:nvSpPr>
-        <p:spPr>
+        </ns0:spPr>
+      </ns0:sp>
+      <ns0:sp>
+        <ns0:nvSpPr>
+          <ns0:cNvPr id="10" name="Text 8"/>
+          <ns0:cNvSpPr/>
+          <ns0:nvPr/>
+        </ns0:nvSpPr>
+        <ns0:spPr>
           <a:xfrm>
             <a:off x="6400800" y="2514600"/>
             <a:ext cx="1097280" cy="210312"/>
@@ -9162,8 +9123,8 @@
           </a:prstGeom>
           <a:noFill/>
           <a:ln/>
-        </p:spPr>
-        <p:txBody>
+        </ns0:spPr>
+        <ns0:txBody>
           <a:bodyPr wrap="square" lIns="508" tIns="508" rIns="508" bIns="508" rtlCol="0" anchor="ctr">
             <a:normAutofit/>
           </a:bodyPr>
@@ -9185,15 +9146,15 @@
             </a:r>
             <a:endParaRPr lang="en-US" sz="820" dirty="0"/>
           </a:p>
-        </p:txBody>
-      </p:sp>
-      <p:sp>
-        <p:nvSpPr>
-          <p:cNvPr id="11" name="Text 9"/>
-          <p:cNvSpPr/>
-          <p:nvPr/>
-        </p:nvSpPr>
-        <p:spPr>
+        </ns0:txBody>
+      </ns0:sp>
+      <ns0:sp>
+        <ns0:nvSpPr>
+          <ns0:cNvPr id="11" name="Text 9"/>
+          <ns0:cNvSpPr/>
+          <ns0:nvPr/>
+        </ns0:nvSpPr>
+        <ns0:spPr>
           <a:xfrm>
             <a:off x="7699248" y="2432304"/>
             <a:ext cx="3621024" cy="621792"/>
@@ -9203,8 +9164,8 @@
           </a:prstGeom>
           <a:noFill/>
           <a:ln/>
-        </p:spPr>
-        <p:txBody>
+        </ns0:spPr>
+        <ns0:txBody>
           <a:bodyPr wrap="square" lIns="508" tIns="508" rIns="508" bIns="508" rtlCol="0" anchor="ctr">
             <a:normAutofit/>
           </a:bodyPr>
@@ -9226,15 +9187,15 @@
             </a:r>
             <a:endParaRPr lang="en-US" sz="1230" dirty="0"/>
           </a:p>
-        </p:txBody>
-      </p:sp>
-      <p:sp>
-        <p:nvSpPr>
-          <p:cNvPr id="12" name="Shape 10"/>
-          <p:cNvSpPr/>
-          <p:nvPr/>
-        </p:nvSpPr>
-        <p:spPr>
+        </ns0:txBody>
+      </ns0:sp>
+      <ns0:sp>
+        <ns0:nvSpPr>
+          <ns0:cNvPr id="12" name="Shape 10"/>
+          <ns0:cNvSpPr/>
+          <ns0:nvPr/>
+        </ns0:nvSpPr>
+        <ns0:spPr>
           <a:xfrm>
             <a:off x="731520" y="3429000"/>
             <a:ext cx="5230368" cy="841248"/>
@@ -9253,15 +9214,15 @@
             </a:solidFill>
             <a:prstDash val="solid"/>
           </a:ln>
-        </p:spPr>
-      </p:sp>
-      <p:sp>
-        <p:nvSpPr>
-          <p:cNvPr id="13" name="Shape 11"/>
-          <p:cNvSpPr/>
-          <p:nvPr/>
-        </p:nvSpPr>
-        <p:spPr>
+        </ns0:spPr>
+      </ns0:sp>
+      <ns0:sp>
+        <ns0:nvSpPr>
+          <ns0:cNvPr id="13" name="Shape 11"/>
+          <ns0:cNvSpPr/>
+          <ns0:nvPr/>
+        </ns0:nvSpPr>
+        <ns0:spPr>
           <a:xfrm>
             <a:off x="859536" y="3593592"/>
             <a:ext cx="1170432" cy="274320"/>
@@ -9280,15 +9241,15 @@
             </a:solidFill>
             <a:prstDash val="solid"/>
           </a:ln>
-        </p:spPr>
-      </p:sp>
-      <p:sp>
-        <p:nvSpPr>
-          <p:cNvPr id="14" name="Text 12"/>
-          <p:cNvSpPr/>
-          <p:nvPr/>
-        </p:nvSpPr>
-        <p:spPr>
+        </ns0:spPr>
+      </ns0:sp>
+      <ns0:sp>
+        <ns0:nvSpPr>
+          <ns0:cNvPr id="14" name="Text 12"/>
+          <ns0:cNvSpPr/>
+          <ns0:nvPr/>
+        </ns0:nvSpPr>
+        <ns0:spPr>
           <a:xfrm>
             <a:off x="896112" y="3611880"/>
             <a:ext cx="1097280" cy="210312"/>
@@ -9298,8 +9259,8 @@
           </a:prstGeom>
           <a:noFill/>
           <a:ln/>
-        </p:spPr>
-        <p:txBody>
+        </ns0:spPr>
+        <ns0:txBody>
           <a:bodyPr wrap="square" lIns="508" tIns="508" rIns="508" bIns="508" rtlCol="0" anchor="ctr">
             <a:normAutofit/>
           </a:bodyPr>
@@ -9321,15 +9282,15 @@
             </a:r>
             <a:endParaRPr lang="en-US" sz="820" dirty="0"/>
           </a:p>
-        </p:txBody>
-      </p:sp>
-      <p:sp>
-        <p:nvSpPr>
-          <p:cNvPr id="15" name="Text 13"/>
-          <p:cNvSpPr/>
-          <p:nvPr/>
-        </p:nvSpPr>
-        <p:spPr>
+        </ns0:txBody>
+      </ns0:sp>
+      <ns0:sp>
+        <ns0:nvSpPr>
+          <ns0:cNvPr id="15" name="Text 13"/>
+          <ns0:cNvSpPr/>
+          <ns0:nvPr/>
+        </ns0:nvSpPr>
+        <ns0:spPr>
           <a:xfrm>
             <a:off x="2194560" y="3529584"/>
             <a:ext cx="3621024" cy="621792"/>
@@ -9339,8 +9300,8 @@
           </a:prstGeom>
           <a:noFill/>
           <a:ln/>
-        </p:spPr>
-        <p:txBody>
+        </ns0:spPr>
+        <ns0:txBody>
           <a:bodyPr wrap="square" lIns="508" tIns="508" rIns="508" bIns="508" rtlCol="0" anchor="ctr">
             <a:normAutofit/>
           </a:bodyPr>
@@ -9362,15 +9323,15 @@
             </a:r>
             <a:endParaRPr lang="en-US" sz="1230" dirty="0"/>
           </a:p>
-        </p:txBody>
-      </p:sp>
-      <p:sp>
-        <p:nvSpPr>
-          <p:cNvPr id="16" name="Shape 14"/>
-          <p:cNvSpPr/>
-          <p:nvPr/>
-        </p:nvSpPr>
-        <p:spPr>
+        </ns0:txBody>
+      </ns0:sp>
+      <ns0:sp>
+        <ns0:nvSpPr>
+          <ns0:cNvPr id="16" name="Shape 14"/>
+          <ns0:cNvSpPr/>
+          <ns0:nvPr/>
+        </ns0:nvSpPr>
+        <ns0:spPr>
           <a:xfrm>
             <a:off x="6236208" y="3429000"/>
             <a:ext cx="5230368" cy="841248"/>
@@ -9389,15 +9350,15 @@
             </a:solidFill>
             <a:prstDash val="solid"/>
           </a:ln>
-        </p:spPr>
-      </p:sp>
-      <p:sp>
-        <p:nvSpPr>
-          <p:cNvPr id="17" name="Shape 15"/>
-          <p:cNvSpPr/>
-          <p:nvPr/>
-        </p:nvSpPr>
-        <p:spPr>
+        </ns0:spPr>
+      </ns0:sp>
+      <ns0:sp>
+        <ns0:nvSpPr>
+          <ns0:cNvPr id="17" name="Shape 15"/>
+          <ns0:cNvSpPr/>
+          <ns0:nvPr/>
+        </ns0:nvSpPr>
+        <ns0:spPr>
           <a:xfrm>
             <a:off x="6364224" y="3593592"/>
             <a:ext cx="1170432" cy="274320"/>
@@ -9416,15 +9377,15 @@
             </a:solidFill>
             <a:prstDash val="solid"/>
           </a:ln>
-        </p:spPr>
-      </p:sp>
-      <p:sp>
-        <p:nvSpPr>
-          <p:cNvPr id="18" name="Text 16"/>
-          <p:cNvSpPr/>
-          <p:nvPr/>
-        </p:nvSpPr>
-        <p:spPr>
+        </ns0:spPr>
+      </ns0:sp>
+      <ns0:sp>
+        <ns0:nvSpPr>
+          <ns0:cNvPr id="18" name="Text 16"/>
+          <ns0:cNvSpPr/>
+          <ns0:nvPr/>
+        </ns0:nvSpPr>
+        <ns0:spPr>
           <a:xfrm>
             <a:off x="6400800" y="3611880"/>
             <a:ext cx="1097280" cy="210312"/>
@@ -9434,8 +9395,8 @@
           </a:prstGeom>
           <a:noFill/>
           <a:ln/>
-        </p:spPr>
-        <p:txBody>
+        </ns0:spPr>
+        <ns0:txBody>
           <a:bodyPr wrap="square" lIns="508" tIns="508" rIns="508" bIns="508" rtlCol="0" anchor="ctr">
             <a:normAutofit/>
           </a:bodyPr>
@@ -9457,15 +9418,15 @@
             </a:r>
             <a:endParaRPr lang="en-US" sz="820" dirty="0"/>
           </a:p>
-        </p:txBody>
-      </p:sp>
-      <p:sp>
-        <p:nvSpPr>
-          <p:cNvPr id="19" name="Text 17"/>
-          <p:cNvSpPr/>
-          <p:nvPr/>
-        </p:nvSpPr>
-        <p:spPr>
+        </ns0:txBody>
+      </ns0:sp>
+      <ns0:sp>
+        <ns0:nvSpPr>
+          <ns0:cNvPr id="19" name="Text 17"/>
+          <ns0:cNvSpPr/>
+          <ns0:nvPr/>
+        </ns0:nvSpPr>
+        <ns0:spPr>
           <a:xfrm>
             <a:off x="7699248" y="3529584"/>
             <a:ext cx="3621024" cy="621792"/>
@@ -9475,8 +9436,8 @@
           </a:prstGeom>
           <a:noFill/>
           <a:ln/>
-        </p:spPr>
-        <p:txBody>
+        </ns0:spPr>
+        <ns0:txBody>
           <a:bodyPr wrap="square" lIns="508" tIns="508" rIns="508" bIns="508" rtlCol="0" anchor="ctr">
             <a:normAutofit/>
           </a:bodyPr>
@@ -9498,15 +9459,15 @@
             </a:r>
             <a:endParaRPr lang="en-US" sz="1230" dirty="0"/>
           </a:p>
-        </p:txBody>
-      </p:sp>
-      <p:sp>
-        <p:nvSpPr>
-          <p:cNvPr id="20" name="Shape 18"/>
-          <p:cNvSpPr/>
-          <p:nvPr/>
-        </p:nvSpPr>
-        <p:spPr>
+        </ns0:txBody>
+      </ns0:sp>
+      <ns0:sp>
+        <ns0:nvSpPr>
+          <ns0:cNvPr id="20" name="Shape 18"/>
+          <ns0:cNvSpPr/>
+          <ns0:nvPr/>
+        </ns0:nvSpPr>
+        <ns0:spPr>
           <a:xfrm>
             <a:off x="731520" y="4526280"/>
             <a:ext cx="10762488" cy="841248"/>
@@ -9525,15 +9486,15 @@
             </a:solidFill>
             <a:prstDash val="solid"/>
           </a:ln>
-        </p:spPr>
-      </p:sp>
-      <p:sp>
-        <p:nvSpPr>
-          <p:cNvPr id="21" name="Shape 19"/>
-          <p:cNvSpPr/>
-          <p:nvPr/>
-        </p:nvSpPr>
-        <p:spPr>
+        </ns0:spPr>
+      </ns0:sp>
+      <ns0:sp>
+        <ns0:nvSpPr>
+          <ns0:cNvPr id="21" name="Shape 19"/>
+          <ns0:cNvSpPr/>
+          <ns0:nvPr/>
+        </ns0:nvSpPr>
+        <ns0:spPr>
           <a:xfrm>
             <a:off x="859536" y="4690872"/>
             <a:ext cx="1234440" cy="274320"/>
@@ -9552,15 +9513,15 @@
             </a:solidFill>
             <a:prstDash val="solid"/>
           </a:ln>
-        </p:spPr>
-      </p:sp>
-      <p:sp>
-        <p:nvSpPr>
-          <p:cNvPr id="22" name="Text 20"/>
-          <p:cNvSpPr/>
-          <p:nvPr/>
-        </p:nvSpPr>
-        <p:spPr>
+        </ns0:spPr>
+      </ns0:sp>
+      <ns0:sp>
+        <ns0:nvSpPr>
+          <ns0:cNvPr id="22" name="Text 20"/>
+          <ns0:cNvSpPr/>
+          <ns0:nvPr/>
+        </ns0:nvSpPr>
+        <ns0:spPr>
           <a:xfrm>
             <a:off x="896112" y="4709160"/>
             <a:ext cx="1161288" cy="210312"/>
@@ -9570,8 +9531,8 @@
           </a:prstGeom>
           <a:noFill/>
           <a:ln/>
-        </p:spPr>
-        <p:txBody>
+        </ns0:spPr>
+        <ns0:txBody>
           <a:bodyPr wrap="square" lIns="508" tIns="508" rIns="508" bIns="508" rtlCol="0" anchor="ctr">
             <a:normAutofit/>
           </a:bodyPr>
@@ -9593,15 +9554,15 @@
             </a:r>
             <a:endParaRPr lang="en-US" sz="820" dirty="0"/>
           </a:p>
-        </p:txBody>
-      </p:sp>
-      <p:sp>
-        <p:nvSpPr>
-          <p:cNvPr id="23" name="Text 21"/>
-          <p:cNvSpPr/>
-          <p:nvPr/>
-        </p:nvSpPr>
-        <p:spPr>
+        </ns0:txBody>
+      </ns0:sp>
+      <ns0:sp>
+        <ns0:nvSpPr>
+          <ns0:cNvPr id="23" name="Text 21"/>
+          <ns0:cNvSpPr/>
+          <ns0:nvPr/>
+        </ns0:nvSpPr>
+        <ns0:spPr>
           <a:xfrm>
             <a:off x="2258568" y="4626864"/>
             <a:ext cx="9089136" cy="621792"/>
@@ -9611,8 +9572,8 @@
           </a:prstGeom>
           <a:noFill/>
           <a:ln/>
-        </p:spPr>
-        <p:txBody>
+        </ns0:spPr>
+        <ns0:txBody>
           <a:bodyPr wrap="square" lIns="508" tIns="508" rIns="508" bIns="508" rtlCol="0" anchor="ctr">
             <a:normAutofit/>
           </a:bodyPr>
@@ -9634,15 +9595,15 @@
             </a:r>
             <a:endParaRPr lang="en-US" sz="1300" dirty="0"/>
           </a:p>
-        </p:txBody>
-      </p:sp>
-      <p:sp>
-        <p:nvSpPr>
-          <p:cNvPr id="24" name="Text 22"/>
-          <p:cNvSpPr/>
-          <p:nvPr/>
-        </p:nvSpPr>
-        <p:spPr>
+        </ns0:txBody>
+      </ns0:sp>
+      <ns0:sp>
+        <ns0:nvSpPr>
+          <ns0:cNvPr id="24" name="Text 22"/>
+          <ns0:cNvSpPr/>
+          <ns0:nvPr/>
+        </ns0:nvSpPr>
+        <ns0:spPr>
           <a:xfrm>
             <a:off x="749808" y="5632704"/>
             <a:ext cx="5760720" cy="219456"/>
@@ -9652,8 +9613,8 @@
           </a:prstGeom>
           <a:noFill/>
           <a:ln/>
-        </p:spPr>
-        <p:txBody>
+        </ns0:spPr>
+        <ns0:txBody>
           <a:bodyPr wrap="square" lIns="508" tIns="508" rIns="508" bIns="508" rtlCol="0" anchor="ctr">
             <a:normAutofit/>
           </a:bodyPr>
@@ -9671,19 +9632,19 @@
                 <a:ea typeface="Arial" pitchFamily="34" charset="-122"/>
                 <a:cs typeface="Arial" pitchFamily="34" charset="-120"/>
               </a:rPr>
-              <a:t>Operatoren gemäß Standardsicherung NRW · gültig ab Abitur 2023</a:t>
+              <a:t/>
             </a:r>
             <a:endParaRPr lang="en-US" sz="940" dirty="0"/>
           </a:p>
-        </p:txBody>
-      </p:sp>
-      <p:sp>
-        <p:nvSpPr>
-          <p:cNvPr id="25" name="Text 23"/>
-          <p:cNvSpPr/>
-          <p:nvPr/>
-        </p:nvSpPr>
-        <p:spPr>
+        </ns0:txBody>
+      </ns0:sp>
+      <ns0:sp>
+        <ns0:nvSpPr>
+          <ns0:cNvPr id="25" name="Text 23"/>
+          <ns0:cNvSpPr/>
+          <ns0:nvPr/>
+        </ns0:nvSpPr>
+        <ns0:spPr>
           <a:xfrm>
             <a:off x="6629400" y="5605272"/>
             <a:ext cx="960120" cy="201168"/>
@@ -9693,8 +9654,8 @@
           </a:prstGeom>
           <a:noFill/>
           <a:ln/>
-        </p:spPr>
-        <p:txBody>
+        </ns0:spPr>
+        <ns0:txBody>
           <a:bodyPr wrap="square" lIns="508" tIns="508" rIns="508" bIns="508" rtlCol="0" anchor="ctr">
             <a:normAutofit/>
           </a:bodyPr>
@@ -9716,15 +9677,15 @@
             </a:r>
             <a:endParaRPr lang="en-US" sz="980" dirty="0"/>
           </a:p>
-        </p:txBody>
-      </p:sp>
-      <p:sp>
-        <p:nvSpPr>
-          <p:cNvPr id="26" name="Shape 24"/>
-          <p:cNvSpPr/>
-          <p:nvPr/>
-        </p:nvSpPr>
-        <p:spPr>
+        </ns0:txBody>
+      </ns0:sp>
+      <ns0:sp>
+        <ns0:nvSpPr>
+          <ns0:cNvPr id="26" name="Shape 24"/>
+          <ns0:cNvSpPr/>
+          <ns0:nvPr/>
+        </ns0:nvSpPr>
+        <ns0:spPr>
           <a:xfrm>
             <a:off x="7635240" y="5513832"/>
             <a:ext cx="1051560" cy="384048"/>
@@ -9745,15 +9706,15 @@
             </a:solidFill>
             <a:prstDash val="solid"/>
           </a:ln>
-        </p:spPr>
-      </p:sp>
-      <p:sp>
-        <p:nvSpPr>
-          <p:cNvPr id="27" name="Text 25"/>
-          <p:cNvSpPr/>
-          <p:nvPr/>
-        </p:nvSpPr>
-        <p:spPr>
+        </ns0:spPr>
+      </ns0:sp>
+      <ns0:sp>
+        <ns0:nvSpPr>
+          <ns0:cNvPr id="27" name="Text 25"/>
+          <ns0:cNvSpPr/>
+          <ns0:nvPr/>
+        </ns0:nvSpPr>
+        <ns0:spPr>
           <a:xfrm>
             <a:off x="7680960" y="5577840"/>
             <a:ext cx="960120" cy="219456"/>
@@ -9763,8 +9724,8 @@
           </a:prstGeom>
           <a:noFill/>
           <a:ln/>
-        </p:spPr>
-        <p:txBody>
+        </ns0:spPr>
+        <ns0:txBody>
           <a:bodyPr wrap="square" lIns="508" tIns="508" rIns="508" bIns="508" rtlCol="0" anchor="ctr">
             <a:normAutofit/>
           </a:bodyPr>
@@ -9786,15 +9747,15 @@
             </a:r>
             <a:endParaRPr lang="en-US" sz="930" dirty="0"/>
           </a:p>
-        </p:txBody>
-      </p:sp>
-      <p:sp>
-        <p:nvSpPr>
-          <p:cNvPr id="28" name="Shape 26"/>
-          <p:cNvSpPr/>
-          <p:nvPr/>
-        </p:nvSpPr>
-        <p:spPr>
+        </ns0:txBody>
+      </ns0:sp>
+      <ns0:sp>
+        <ns0:nvSpPr>
+          <ns0:cNvPr id="28" name="Shape 26"/>
+          <ns0:cNvSpPr/>
+          <ns0:nvPr/>
+        </ns0:nvSpPr>
+        <ns0:spPr>
           <a:xfrm>
             <a:off x="8842248" y="5513832"/>
             <a:ext cx="1051560" cy="384048"/>
@@ -9815,15 +9776,15 @@
             </a:solidFill>
             <a:prstDash val="solid"/>
           </a:ln>
-        </p:spPr>
-      </p:sp>
-      <p:sp>
-        <p:nvSpPr>
-          <p:cNvPr id="29" name="Text 27"/>
-          <p:cNvSpPr/>
-          <p:nvPr/>
-        </p:nvSpPr>
-        <p:spPr>
+        </ns0:spPr>
+      </ns0:sp>
+      <ns0:sp>
+        <ns0:nvSpPr>
+          <ns0:cNvPr id="29" name="Text 27"/>
+          <ns0:cNvSpPr/>
+          <ns0:nvPr/>
+        </ns0:nvSpPr>
+        <ns0:spPr>
           <a:xfrm>
             <a:off x="8887968" y="5577840"/>
             <a:ext cx="960120" cy="219456"/>
@@ -9833,8 +9794,8 @@
           </a:prstGeom>
           <a:noFill/>
           <a:ln/>
-        </p:spPr>
-        <p:txBody>
+        </ns0:spPr>
+        <ns0:txBody>
           <a:bodyPr wrap="square" lIns="508" tIns="508" rIns="508" bIns="508" rtlCol="0" anchor="ctr">
             <a:normAutofit/>
           </a:bodyPr>
@@ -9856,15 +9817,15 @@
             </a:r>
             <a:endParaRPr lang="en-US" sz="930" dirty="0"/>
           </a:p>
-        </p:txBody>
-      </p:sp>
-      <p:sp>
-        <p:nvSpPr>
-          <p:cNvPr id="30" name="Shape 28"/>
-          <p:cNvSpPr/>
-          <p:nvPr/>
-        </p:nvSpPr>
-        <p:spPr>
+        </ns0:txBody>
+      </ns0:sp>
+      <ns0:sp>
+        <ns0:nvSpPr>
+          <ns0:cNvPr id="30" name="Shape 28"/>
+          <ns0:cNvSpPr/>
+          <ns0:nvPr/>
+        </ns0:nvSpPr>
+        <ns0:spPr>
           <a:xfrm>
             <a:off x="10049256" y="5513832"/>
             <a:ext cx="1051560" cy="384048"/>
@@ -9885,15 +9846,15 @@
             </a:solidFill>
             <a:prstDash val="solid"/>
           </a:ln>
-        </p:spPr>
-      </p:sp>
-      <p:sp>
-        <p:nvSpPr>
-          <p:cNvPr id="31" name="Text 29"/>
-          <p:cNvSpPr/>
-          <p:nvPr/>
-        </p:nvSpPr>
-        <p:spPr>
+        </ns0:spPr>
+      </ns0:sp>
+      <ns0:sp>
+        <ns0:nvSpPr>
+          <ns0:cNvPr id="31" name="Text 29"/>
+          <ns0:cNvSpPr/>
+          <ns0:nvPr/>
+        </ns0:nvSpPr>
+        <ns0:spPr>
           <a:xfrm>
             <a:off x="10094976" y="5577840"/>
             <a:ext cx="960120" cy="219456"/>
@@ -9903,8 +9864,8 @@
           </a:prstGeom>
           <a:noFill/>
           <a:ln/>
-        </p:spPr>
-        <p:txBody>
+        </ns0:spPr>
+        <ns0:txBody>
           <a:bodyPr wrap="square" lIns="508" tIns="508" rIns="508" bIns="508" rtlCol="0" anchor="ctr">
             <a:normAutofit/>
           </a:bodyPr>
@@ -9926,19 +9887,19 @@
             </a:r>
             <a:endParaRPr lang="en-US" sz="930" dirty="0"/>
           </a:p>
-        </p:txBody>
-      </p:sp>
-      <p:sp>
-        <p:nvSpPr>
-          <p:cNvPr id="25" name="Slide Number Placeholder 0"/>
-          <p:cNvSpPr>
+        </ns0:txBody>
+      </ns0:sp>
+      <ns0:sp>
+        <ns0:nvSpPr>
+          <ns0:cNvPr id="25" name="Slide Number Placeholder 0"/>
+          <ns0:cNvSpPr>
             <a:spLocks noGrp="1"/>
-          </p:cNvSpPr>
-          <p:nvPr>
-            <p:ph type="sldNum" sz="quarter" idx="4294967295"/>
-          </p:nvPr>
-        </p:nvSpPr>
-        <p:spPr>
+          </ns0:cNvSpPr>
+          <ns0:nvPr>
+            <ns0:ph type="sldNum" sz="quarter" idx="4294967295"/>
+          </ns0:nvPr>
+        </ns0:nvSpPr>
+        <ns0:spPr>
           <a:xfrm>
             <a:off x="11658600" y="6446520"/>
             <a:ext cx="274320" cy="182880"/>
@@ -9948,11 +9909,11 @@
           </a:prstGeom>
           <a:extLst>
             <a:ext uri="{C572A759-6A51-4108-AA02-DFA0A04FC94B}">
-              <ma14:wrappingTextBoxFlag xmlns:ma14="http://schemas.microsoft.com/office/mac/drawingml/2011/main" val="0"/>
+              <ns2:wrappingTextBoxFlag val="0"/>
             </a:ext>
           </a:extLst>
-        </p:spPr>
-        <p:txBody>
+        </ns0:spPr>
+        <ns0:txBody>
           <a:bodyPr/>
           <a:lstStyle>
             <a:lvl1pPr>
@@ -9974,14 +9935,14 @@
             </a:fld>
             <a:endParaRPr lang="en-US"/>
           </a:p>
-        </p:txBody>
-      </p:sp>
-    </p:spTree>
-  </p:cSld>
-  <p:clrMapOvr>
+        </ns0:txBody>
+      </ns0:sp>
+    </ns0:spTree>
+  </ns0:cSld>
+  <ns0:clrMapOvr>
     <a:masterClrMapping/>
-  </p:clrMapOvr>
-</p:sld>
+  </ns0:clrMapOvr>
+</ns0:sld>
 </file>
 
 <file path=ppt/theme/theme1.xml><?xml version="1.0" encoding="utf-8"?>

</xml_diff>